<commit_message>
Deck: add the voice briefing slide
Eleventh slide covering the briefing recorder Muthu built, and where it goes.

Framed honestly, because the pitch cannot claim what is not wired: the consent
capture is built, and the tone analysis is built and already running — today it
reads the twenty-eight written RM notes and produces the guidance the slide
quotes verbatim from the cache. Pointing the same pipeline at a consented
transcript is the roadmap, and the footer says so, along with the reason no
transcript was fabricated.

It also earns its place in the narrative rather than being bolted on: the whole
deck opens with a note nobody read, and this is the slide where that loop
closes.

Deck now 11 slides, validates clean, every element in bounds, worst image
distortion 0.1%.

Co-Authored-By: Claude Opus 5 <noreply@anthropic.com>
</commit_message>
<xml_diff>
--- a/docs/Foresight-RM-Pitch.pptx
+++ b/docs/Foresight-RM-Pitch.pptx
@@ -15,9 +15,10 @@
     <p:sldId id="263" r:id="rId9"/>
     <p:sldId id="264" r:id="rId10"/>
     <p:sldId id="265" r:id="rId11"/>
+    <p:sldId id="266" r:id="rId12"/>
   </p:sldIdLst>
   <p:notesMasterIdLst>
-    <p:notesMasterId r:id="rId12"/>
+    <p:notesMasterId r:id="rId13"/>
   </p:notesMasterIdLst>
   <p:sldSz cx="12192000" cy="6858000"/>
   <p:notesSz cx="6858000" cy="12192000"/>
@@ -599,7 +600,7 @@
           <a:p>
             <a:r>
               <a:rPr lang="en-US" dirty="0"/>
-              <a:t>Close on these three sentences. Then hand over to the demo.</a:t>
+              <a:t>If asked about the recorder: consent capture is built, the analysis is built and running on written notes today. The audio input is the piece we did not wire, deliberately, because there is no transcript in the dataset and we were not going to fake one.</a:t>
             </a:r>
             <a:endParaRPr lang="en-US" dirty="0"/>
           </a:p>
@@ -623,6 +624,94 @@
             <a:fld id="{F7021451-1387-4CA6-816F-3879F97B5CBC}" type="slidenum">
               <a:rPr lang="en-US"/>
               <a:t>10</a:t>
+            </a:fld>
+            <a:endParaRPr lang="en-US"/>
+          </a:p>
+        </p:txBody>
+      </p:sp>
+    </p:spTree>
+    <p:extLst>
+      <p:ext uri="{BB962C8B-B14F-4D97-AF65-F5344CB8AC3E}">
+        <p14:creationId xmlns:p14="http://schemas.microsoft.com/office/powerpoint/2010/main" val="1024086991"/>
+      </p:ext>
+    </p:extLst>
+  </p:cSld>
+  <p:clrMapOvr>
+    <a:masterClrMapping/>
+  </p:clrMapOvr>
+</p:notes>
+</file>
+
+<file path=ppt/notesSlides/notesSlide11.xml><?xml version="1.0" encoding="utf-8"?>
+<p:notes xmlns:a="http://schemas.openxmlformats.org/drawingml/2006/main" xmlns:r="http://schemas.openxmlformats.org/officeDocument/2006/relationships" xmlns:p="http://schemas.openxmlformats.org/presentationml/2006/main">
+  <p:cSld>
+    <p:spTree>
+      <p:nvGrpSpPr>
+        <p:cNvPr id="1" name=""/>
+        <p:cNvGrpSpPr/>
+        <p:nvPr/>
+      </p:nvGrpSpPr>
+      <p:grpSpPr>
+        <a:xfrm>
+          <a:off x="0" y="0"/>
+          <a:ext cx="0" cy="0"/>
+          <a:chOff x="0" y="0"/>
+          <a:chExt cx="0" cy="0"/>
+        </a:xfrm>
+      </p:grpSpPr>
+      <p:sp>
+        <p:nvSpPr>
+          <p:cNvPr id="2" name="Slide Image Placeholder 1"/>
+          <p:cNvSpPr>
+            <a:spLocks noGrp="1" noRot="1" noChangeAspect="1"/>
+          </p:cNvSpPr>
+          <p:nvPr>
+            <p:ph type="sldImg"/>
+          </p:nvPr>
+        </p:nvSpPr>
+        <p:spPr/>
+      </p:sp>
+      <p:sp>
+        <p:nvSpPr>
+          <p:cNvPr id="3" name="Notes Placeholder 2"/>
+          <p:cNvSpPr>
+            <a:spLocks noGrp="1"/>
+          </p:cNvSpPr>
+          <p:nvPr>
+            <p:ph type="body" idx="1"/>
+          </p:nvPr>
+        </p:nvSpPr>
+        <p:spPr/>
+        <p:txBody>
+          <a:bodyPr/>
+          <a:lstStyle/>
+          <a:p>
+            <a:r>
+              <a:rPr lang="en-US" dirty="0"/>
+              <a:t>Close on these three sentences. Then hand over to the demo.</a:t>
+            </a:r>
+            <a:endParaRPr lang="en-US" dirty="0"/>
+          </a:p>
+        </p:txBody>
+      </p:sp>
+      <p:sp>
+        <p:nvSpPr>
+          <p:cNvPr id="4" name="Slide Number Placeholder 3"/>
+          <p:cNvSpPr>
+            <a:spLocks noGrp="1"/>
+          </p:cNvSpPr>
+          <p:nvPr>
+            <p:ph type="sldNum" sz="quarter" idx="10"/>
+          </p:nvPr>
+        </p:nvSpPr>
+        <p:spPr/>
+        <p:txBody>
+          <a:bodyPr/>
+          <a:lstStyle/>
+          <a:p>
+            <a:fld id="{F7021451-1387-4CA6-816F-3879F97B5CBC}" type="slidenum">
+              <a:rPr lang="en-US"/>
+              <a:t>11</a:t>
             </a:fld>
             <a:endParaRPr lang="en-US"/>
           </a:p>
@@ -1869,6 +1958,518 @@
     <p:bg>
       <p:bgPr>
         <a:solidFill>
+          <a:srgbClr val="F6F7F9"/>
+        </a:solidFill>
+      </p:bgPr>
+    </p:bg>
+    <p:spTree>
+      <p:nvGrpSpPr>
+        <p:cNvPr id="1" name=""/>
+        <p:cNvGrpSpPr/>
+        <p:nvPr/>
+      </p:nvGrpSpPr>
+      <p:grpSpPr>
+        <a:xfrm>
+          <a:off x="0" y="0"/>
+          <a:ext cx="0" cy="0"/>
+          <a:chOff x="0" y="0"/>
+          <a:chExt cx="0" cy="0"/>
+        </a:xfrm>
+      </p:grpSpPr>
+      <p:sp>
+        <p:nvSpPr>
+          <p:cNvPr id="2" name="Text 0"/>
+          <p:cNvSpPr txBox="1"/>
+          <p:nvPr/>
+        </p:nvSpPr>
+        <p:spPr>
+          <a:xfrm>
+            <a:off x="640080" y="502920"/>
+            <a:ext cx="8229600" cy="256032"/>
+          </a:xfrm>
+          <a:prstGeom prst="rect">
+            <a:avLst/>
+          </a:prstGeom>
+          <a:noFill/>
+          <a:ln/>
+        </p:spPr>
+        <p:txBody>
+          <a:bodyPr wrap="square" lIns="0" tIns="0" rIns="0" bIns="0" rtlCol="0" anchor="ctr"/>
+          <a:lstStyle/>
+          <a:p>
+            <a:pPr indent="0" marL="0">
+              <a:buNone/>
+            </a:pPr>
+            <a:r>
+              <a:rPr lang="en-US" sz="1100" spc="300" kern="0" dirty="0">
+                <a:solidFill>
+                  <a:srgbClr val="A68430"/>
+                </a:solidFill>
+                <a:latin typeface="Calibri" pitchFamily="34" charset="0"/>
+                <a:ea typeface="Calibri" pitchFamily="34" charset="-122"/>
+                <a:cs typeface="Calibri" pitchFamily="34" charset="-120"/>
+              </a:rPr>
+              <a:t>WHERE THIS GOES NEXT</a:t>
+            </a:r>
+            <a:endParaRPr lang="en-US" sz="1100" dirty="0"/>
+          </a:p>
+        </p:txBody>
+      </p:sp>
+      <p:sp>
+        <p:nvSpPr>
+          <p:cNvPr id="3" name="Text 1"/>
+          <p:cNvSpPr txBox="1"/>
+          <p:nvPr/>
+        </p:nvSpPr>
+        <p:spPr>
+          <a:xfrm>
+            <a:off x="640080" y="868680"/>
+            <a:ext cx="10881360" cy="777240"/>
+          </a:xfrm>
+          <a:prstGeom prst="rect">
+            <a:avLst/>
+          </a:prstGeom>
+          <a:noFill/>
+          <a:ln/>
+        </p:spPr>
+        <p:txBody>
+          <a:bodyPr wrap="square" lIns="0" tIns="0" rIns="0" bIns="0" rtlCol="0" anchor="t"/>
+          <a:lstStyle/>
+          <a:p>
+            <a:pPr indent="0" marL="0">
+              <a:buNone/>
+            </a:pPr>
+            <a:r>
+              <a:rPr lang="en-US" sz="3400" spc="350" kern="0" dirty="0">
+                <a:solidFill>
+                  <a:srgbClr val="141E55"/>
+                </a:solidFill>
+                <a:latin typeface="Calibri" pitchFamily="34" charset="0"/>
+                <a:ea typeface="Calibri" pitchFamily="34" charset="-122"/>
+                <a:cs typeface="Calibri" pitchFamily="34" charset="-120"/>
+              </a:rPr>
+              <a:t>CLOSING THE LOOP</a:t>
+            </a:r>
+            <a:endParaRPr lang="en-US" sz="3400" dirty="0"/>
+          </a:p>
+        </p:txBody>
+      </p:sp>
+      <p:sp>
+        <p:nvSpPr>
+          <p:cNvPr id="4" name="Text 2"/>
+          <p:cNvSpPr txBox="1"/>
+          <p:nvPr/>
+        </p:nvSpPr>
+        <p:spPr>
+          <a:xfrm>
+            <a:off x="640080" y="1783080"/>
+            <a:ext cx="10881360" cy="731520"/>
+          </a:xfrm>
+          <a:prstGeom prst="rect">
+            <a:avLst/>
+          </a:prstGeom>
+          <a:noFill/>
+          <a:ln/>
+        </p:spPr>
+        <p:txBody>
+          <a:bodyPr wrap="square" lIns="0" tIns="0" rIns="0" bIns="0" rtlCol="0" anchor="ctr"/>
+          <a:lstStyle/>
+          <a:p>
+            <a:pPr indent="0" marL="0">
+              <a:lnSpc>
+                <a:spcPts val="2400"/>
+              </a:lnSpc>
+              <a:buNone/>
+            </a:pPr>
+            <a:r>
+              <a:rPr lang="en-US" sz="1400" dirty="0">
+                <a:solidFill>
+                  <a:srgbClr val="5E6976"/>
+                </a:solidFill>
+                <a:latin typeface="Calibri" pitchFamily="34" charset="0"/>
+                <a:ea typeface="Calibri" pitchFamily="34" charset="-122"/>
+                <a:cs typeface="Calibri" pitchFamily="34" charset="-120"/>
+              </a:rPr>
+              <a:t>The tone analysis already runs. Today it reads the twenty-eight written RM notes and produces the guidance below. Point the same pipeline at a consented meeting transcript and it reads the room instead.</a:t>
+            </a:r>
+            <a:endParaRPr lang="en-US" sz="1400" dirty="0"/>
+          </a:p>
+        </p:txBody>
+      </p:sp>
+      <p:sp>
+        <p:nvSpPr>
+          <p:cNvPr id="5" name="Shape 3"/>
+          <p:cNvSpPr/>
+          <p:nvPr/>
+        </p:nvSpPr>
+        <p:spPr>
+          <a:xfrm>
+            <a:off x="640080" y="2697480"/>
+            <a:ext cx="5349240" cy="2148840"/>
+          </a:xfrm>
+          <a:prstGeom prst="roundRect">
+            <a:avLst>
+              <a:gd name="adj" fmla="val 2553"/>
+            </a:avLst>
+          </a:prstGeom>
+          <a:solidFill>
+            <a:srgbClr val="FFFFFF"/>
+          </a:solidFill>
+          <a:ln w="12700">
+            <a:solidFill>
+              <a:srgbClr val="CCD0D1"/>
+            </a:solidFill>
+            <a:prstDash val="solid"/>
+          </a:ln>
+        </p:spPr>
+      </p:sp>
+      <p:sp>
+        <p:nvSpPr>
+          <p:cNvPr id="6" name="Text 4"/>
+          <p:cNvSpPr txBox="1"/>
+          <p:nvPr/>
+        </p:nvSpPr>
+        <p:spPr>
+          <a:xfrm>
+            <a:off x="914400" y="2880360"/>
+            <a:ext cx="4846320" cy="274320"/>
+          </a:xfrm>
+          <a:prstGeom prst="rect">
+            <a:avLst/>
+          </a:prstGeom>
+          <a:noFill/>
+          <a:ln/>
+        </p:spPr>
+        <p:txBody>
+          <a:bodyPr wrap="square" lIns="0" tIns="0" rIns="0" bIns="0" rtlCol="0" anchor="ctr"/>
+          <a:lstStyle/>
+          <a:p>
+            <a:pPr indent="0" marL="0">
+              <a:buNone/>
+            </a:pPr>
+            <a:r>
+              <a:rPr lang="en-US" sz="1050" spc="200" kern="0" dirty="0">
+                <a:solidFill>
+                  <a:srgbClr val="2C6A4F"/>
+                </a:solidFill>
+                <a:latin typeface="Calibri" pitchFamily="34" charset="0"/>
+                <a:ea typeface="Calibri" pitchFamily="34" charset="-122"/>
+                <a:cs typeface="Calibri" pitchFamily="34" charset="-120"/>
+              </a:rPr>
+              <a:t>LIVE TODAY  ·  FROM WRITTEN NOTES</a:t>
+            </a:r>
+            <a:endParaRPr lang="en-US" sz="1050" dirty="0"/>
+          </a:p>
+        </p:txBody>
+      </p:sp>
+      <p:sp>
+        <p:nvSpPr>
+          <p:cNvPr id="7" name="Text 5"/>
+          <p:cNvSpPr txBox="1"/>
+          <p:nvPr/>
+        </p:nvSpPr>
+        <p:spPr>
+          <a:xfrm>
+            <a:off x="914400" y="3246120"/>
+            <a:ext cx="4846320" cy="1371600"/>
+          </a:xfrm>
+          <a:prstGeom prst="rect">
+            <a:avLst/>
+          </a:prstGeom>
+          <a:noFill/>
+          <a:ln/>
+        </p:spPr>
+        <p:txBody>
+          <a:bodyPr wrap="square" lIns="0" tIns="0" rIns="0" bIns="0" rtlCol="0" anchor="ctr"/>
+          <a:lstStyle/>
+          <a:p>
+            <a:pPr indent="0" marL="0">
+              <a:lnSpc>
+                <a:spcPts val="2200"/>
+              </a:lnSpc>
+              <a:buNone/>
+            </a:pPr>
+            <a:r>
+              <a:rPr lang="en-US" sz="1350" i="1" dirty="0">
+                <a:solidFill>
+                  <a:srgbClr val="141E55"/>
+                </a:solidFill>
+                <a:latin typeface="Calibri" pitchFamily="34" charset="0"/>
+                <a:ea typeface="Calibri" pitchFamily="34" charset="-122"/>
+                <a:cs typeface="Calibri" pitchFamily="34" charset="-120"/>
+              </a:rPr>
+              <a:t>“Speak with respect for his entrepreneurial conviction but be direct and grounded in numbers, gently challenging the concentration risk without dismissing his market view.”</a:t>
+            </a:r>
+            <a:endParaRPr lang="en-US" sz="1350" dirty="0"/>
+          </a:p>
+        </p:txBody>
+      </p:sp>
+      <p:sp>
+        <p:nvSpPr>
+          <p:cNvPr id="8" name="Shape 6"/>
+          <p:cNvSpPr/>
+          <p:nvPr/>
+        </p:nvSpPr>
+        <p:spPr>
+          <a:xfrm>
+            <a:off x="6172200" y="2697480"/>
+            <a:ext cx="5349240" cy="2148840"/>
+          </a:xfrm>
+          <a:prstGeom prst="roundRect">
+            <a:avLst>
+              <a:gd name="adj" fmla="val 2553"/>
+            </a:avLst>
+          </a:prstGeom>
+          <a:solidFill>
+            <a:srgbClr val="FBF8F0"/>
+          </a:solidFill>
+          <a:ln w="12700">
+            <a:solidFill>
+              <a:srgbClr val="A68430"/>
+            </a:solidFill>
+            <a:prstDash val="solid"/>
+          </a:ln>
+        </p:spPr>
+      </p:sp>
+      <p:sp>
+        <p:nvSpPr>
+          <p:cNvPr id="9" name="Text 7"/>
+          <p:cNvSpPr txBox="1"/>
+          <p:nvPr/>
+        </p:nvSpPr>
+        <p:spPr>
+          <a:xfrm>
+            <a:off x="6446520" y="2880360"/>
+            <a:ext cx="4846320" cy="274320"/>
+          </a:xfrm>
+          <a:prstGeom prst="rect">
+            <a:avLst/>
+          </a:prstGeom>
+          <a:noFill/>
+          <a:ln/>
+        </p:spPr>
+        <p:txBody>
+          <a:bodyPr wrap="square" lIns="0" tIns="0" rIns="0" bIns="0" rtlCol="0" anchor="ctr"/>
+          <a:lstStyle/>
+          <a:p>
+            <a:pPr indent="0" marL="0">
+              <a:buNone/>
+            </a:pPr>
+            <a:r>
+              <a:rPr lang="en-US" sz="1050" spc="200" kern="0" dirty="0">
+                <a:solidFill>
+                  <a:srgbClr val="A68430"/>
+                </a:solidFill>
+                <a:latin typeface="Calibri" pitchFamily="34" charset="0"/>
+                <a:ea typeface="Calibri" pitchFamily="34" charset="-122"/>
+                <a:cs typeface="Calibri" pitchFamily="34" charset="-120"/>
+              </a:rPr>
+              <a:t>NEXT  ·  FROM A CONSENTED TRANSCRIPT</a:t>
+            </a:r>
+            <a:endParaRPr lang="en-US" sz="1050" dirty="0"/>
+          </a:p>
+        </p:txBody>
+      </p:sp>
+      <p:sp>
+        <p:nvSpPr>
+          <p:cNvPr id="10" name="Text 8"/>
+          <p:cNvSpPr txBox="1"/>
+          <p:nvPr/>
+        </p:nvSpPr>
+        <p:spPr>
+          <a:xfrm>
+            <a:off x="6537960" y="3246120"/>
+            <a:ext cx="4709160" cy="1371600"/>
+          </a:xfrm>
+          <a:prstGeom prst="rect">
+            <a:avLst/>
+          </a:prstGeom>
+          <a:noFill/>
+          <a:ln/>
+        </p:spPr>
+        <p:txBody>
+          <a:bodyPr wrap="square" lIns="0" tIns="0" rIns="0" bIns="0" rtlCol="0" anchor="ctr"/>
+          <a:lstStyle/>
+          <a:p>
+            <a:pPr marL="342900" indent="-342900">
+              <a:spcAft>
+                <a:spcPts val="700"/>
+              </a:spcAft>
+              <a:buSzPct val="100000"/>
+              <a:buChar char="•"/>
+            </a:pPr>
+            <a:r>
+              <a:rPr lang="en-US" sz="1250" dirty="0">
+                <a:solidFill>
+                  <a:srgbClr val="5E6976"/>
+                </a:solidFill>
+                <a:latin typeface="Calibri" pitchFamily="34" charset="0"/>
+                <a:ea typeface="Calibri" pitchFamily="34" charset="-122"/>
+                <a:cs typeface="Calibri" pitchFamily="34" charset="-120"/>
+              </a:rPr>
+              <a:t>Consent captured before anything records.</a:t>
+            </a:r>
+            <a:endParaRPr lang="en-US" sz="1250" dirty="0"/>
+          </a:p>
+          <a:p>
+            <a:pPr marL="342900" indent="-342900">
+              <a:spcAft>
+                <a:spcPts val="700"/>
+              </a:spcAft>
+              <a:buSzPct val="100000"/>
+              <a:buChar char="•"/>
+            </a:pPr>
+            <a:r>
+              <a:rPr lang="en-US" sz="1250" dirty="0">
+                <a:solidFill>
+                  <a:srgbClr val="5E6976"/>
+                </a:solidFill>
+                <a:latin typeface="Calibri" pitchFamily="34" charset="0"/>
+                <a:ea typeface="Calibri" pitchFamily="34" charset="-122"/>
+                <a:cs typeface="Calibri" pitchFamily="34" charset="-120"/>
+              </a:rPr>
+              <a:t>Tone and concerns extracted from the meeting.</a:t>
+            </a:r>
+            <a:endParaRPr lang="en-US" sz="1250" dirty="0"/>
+          </a:p>
+          <a:p>
+            <a:pPr marL="342900" indent="-342900">
+              <a:spcAft>
+                <a:spcPts val="700"/>
+              </a:spcAft>
+              <a:buSzPct val="100000"/>
+              <a:buChar char="•"/>
+            </a:pPr>
+            <a:r>
+              <a:rPr lang="en-US" sz="1250" dirty="0">
+                <a:solidFill>
+                  <a:srgbClr val="5E6976"/>
+                </a:solidFill>
+                <a:latin typeface="Calibri" pitchFamily="34" charset="0"/>
+                <a:ea typeface="Calibri" pitchFamily="34" charset="-122"/>
+                <a:cs typeface="Calibri" pitchFamily="34" charset="-120"/>
+              </a:rPr>
+              <a:t>Those become constraints — so the gate holds a</a:t>
+            </a:r>
+            <a:endParaRPr lang="en-US" sz="1250" dirty="0"/>
+          </a:p>
+          <a:p>
+            <a:pPr indent="0" marL="0">
+              <a:spcAft>
+                <a:spcPts val="700"/>
+              </a:spcAft>
+              <a:buNone/>
+            </a:pPr>
+            <a:r>
+              <a:rPr lang="en-US" sz="1250" dirty="0">
+                <a:solidFill>
+                  <a:srgbClr val="5E6976"/>
+                </a:solidFill>
+                <a:latin typeface="Calibri" pitchFamily="34" charset="0"/>
+                <a:ea typeface="Calibri" pitchFamily="34" charset="-122"/>
+                <a:cs typeface="Calibri" pitchFamily="34" charset="-120"/>
+              </a:rPr>
+              <a:t>    recommendation the client is not ready to hear.</a:t>
+            </a:r>
+            <a:endParaRPr lang="en-US" sz="1250" dirty="0"/>
+          </a:p>
+        </p:txBody>
+      </p:sp>
+      <p:sp>
+        <p:nvSpPr>
+          <p:cNvPr id="11" name="Text 9"/>
+          <p:cNvSpPr txBox="1"/>
+          <p:nvPr/>
+        </p:nvSpPr>
+        <p:spPr>
+          <a:xfrm>
+            <a:off x="640080" y="5120640"/>
+            <a:ext cx="10881360" cy="640080"/>
+          </a:xfrm>
+          <a:prstGeom prst="rect">
+            <a:avLst/>
+          </a:prstGeom>
+          <a:noFill/>
+          <a:ln/>
+        </p:spPr>
+        <p:txBody>
+          <a:bodyPr wrap="square" lIns="0" tIns="0" rIns="0" bIns="0" rtlCol="0" anchor="ctr"/>
+          <a:lstStyle/>
+          <a:p>
+            <a:pPr indent="0" marL="0">
+              <a:lnSpc>
+                <a:spcPts val="2400"/>
+              </a:lnSpc>
+              <a:buNone/>
+            </a:pPr>
+            <a:r>
+              <a:rPr lang="en-US" sz="1600" dirty="0">
+                <a:solidFill>
+                  <a:srgbClr val="141E55"/>
+                </a:solidFill>
+                <a:latin typeface="Calibri" pitchFamily="34" charset="0"/>
+                <a:ea typeface="Calibri" pitchFamily="34" charset="-122"/>
+                <a:cs typeface="Calibri" pitchFamily="34" charset="-120"/>
+              </a:rPr>
+              <a:t>Every other tool summarises the meeting and files a note. Ours feeds what was said back into what may be said next.</a:t>
+            </a:r>
+            <a:endParaRPr lang="en-US" sz="1600" dirty="0"/>
+          </a:p>
+        </p:txBody>
+      </p:sp>
+      <p:sp>
+        <p:nvSpPr>
+          <p:cNvPr id="12" name="Text 10"/>
+          <p:cNvSpPr txBox="1"/>
+          <p:nvPr/>
+        </p:nvSpPr>
+        <p:spPr>
+          <a:xfrm>
+            <a:off x="640080" y="6355080"/>
+            <a:ext cx="10881360" cy="274320"/>
+          </a:xfrm>
+          <a:prstGeom prst="rect">
+            <a:avLst/>
+          </a:prstGeom>
+          <a:noFill/>
+          <a:ln/>
+        </p:spPr>
+        <p:txBody>
+          <a:bodyPr wrap="square" lIns="0" tIns="0" rIns="0" bIns="0" rtlCol="0" anchor="ctr"/>
+          <a:lstStyle/>
+          <a:p>
+            <a:pPr indent="0" marL="0">
+              <a:buNone/>
+            </a:pPr>
+            <a:r>
+              <a:rPr lang="en-US" sz="950" dirty="0">
+                <a:solidFill>
+                  <a:srgbClr val="8B96A3"/>
+                </a:solidFill>
+                <a:latin typeface="Calibri" pitchFamily="34" charset="0"/>
+                <a:ea typeface="Calibri" pitchFamily="34" charset="-122"/>
+                <a:cs typeface="Calibri" pitchFamily="34" charset="-120"/>
+              </a:rPr>
+              <a:t>No transcript exists in the supplied dataset, so none was fabricated — the analysis runs on the real notes instead</a:t>
+            </a:r>
+            <a:endParaRPr lang="en-US" sz="950" dirty="0"/>
+          </a:p>
+        </p:txBody>
+      </p:sp>
+    </p:spTree>
+  </p:cSld>
+  <p:clrMapOvr>
+    <a:masterClrMapping/>
+  </p:clrMapOvr>
+</p:sld>
+</file>
+
+<file path=ppt/slides/slide11.xml><?xml version="1.0" encoding="utf-8"?>
+<p:sld xmlns:a="http://schemas.openxmlformats.org/drawingml/2006/main" xmlns:r="http://schemas.openxmlformats.org/officeDocument/2006/relationships" xmlns:p="http://schemas.openxmlformats.org/presentationml/2006/main">
+  <p:cSld name="Slide 11">
+    <p:bg>
+      <p:bgPr>
+        <a:solidFill>
           <a:srgbClr val="141E55"/>
         </a:solidFill>
       </p:bgPr>

</xml_diff>

<commit_message>
deck: surface the Interactive Foresight Stress Simulator on slide 7
The simulator had zero mentions anywhere in the deck. Slide 7 now carries
both scales of "what could happen next": Lau's LTV ladder computed from his
credit facility on the left, and the four-scenario book-wide re-ranking on
the right, captured with Hormuz Blockade selected.

- new capture screens/40-simulator.png, cropped to c-simulator.png
- footer states plainly that the scenario definitions are ours while every
  figure quoted inside them is read from the dataset
- speaker note rewritten to cover both scales and that caveat

Co-Authored-By: Claude Opus 5 <noreply@anthropic.com>
</commit_message>
<xml_diff>
--- a/docs/Foresight-RM-Pitch.pptx
+++ b/docs/Foresight-RM-Pitch.pptx
@@ -1305,7 +1305,7 @@
           <a:p>
             <a:r>
               <a:rPr lang="en-US" dirty="0"/>
-              <a:t>The brief asks what could happen next. These loan-to-value figures are computed from the actual credit facility under collateral shocks, not estimated.</a:t>
+              <a:t>The brief asks what could happen next, and the answer works at two scales. Per client, the loan-to-value figures are computed from the actual credit facility under collateral shocks. Across the book, four macro scenarios re-rank all twenty clients in place — a Middle East oil shock moves Lau to the top of the list. If asked: the scenario definitions are ours, and every figure quoted inside them is read from the dataset.</a:t>
             </a:r>
             <a:endParaRPr lang="en-US" dirty="0"/>
           </a:p>
@@ -5936,7 +5936,7 @@
                 <a:ea typeface="Calibri" pitchFamily="34" charset="-122"/>
                 <a:cs typeface="Calibri" pitchFamily="34" charset="-120"/>
               </a:rPr>
-              <a:t>A 5% FALL TRIGGERS THE MARGIN CALL</a:t>
+              <a:t>ONE CLIENT, AND THE WHOLE BOOK</a:t>
             </a:r>
             <a:endParaRPr lang="en-US" sz="3400" dirty="0"/>
           </a:p>
@@ -5950,8 +5950,8 @@
         </p:nvSpPr>
         <p:spPr>
           <a:xfrm>
-            <a:off x="640080" y="1874520"/>
-            <a:ext cx="4480560" cy="1188720"/>
+            <a:off x="640080" y="1828800"/>
+            <a:ext cx="4572000" cy="1005840"/>
           </a:xfrm>
           <a:prstGeom prst="rect">
             <a:avLst/>
@@ -5965,12 +5965,12 @@
           <a:p>
             <a:pPr indent="0" marL="0">
               <a:lnSpc>
-                <a:spcPts val="2600"/>
+                <a:spcPts val="2500"/>
               </a:lnSpc>
               <a:buNone/>
             </a:pPr>
             <a:r>
-              <a:rPr lang="en-US" sz="1650" dirty="0">
+              <a:rPr lang="en-US" sz="1600" dirty="0">
                 <a:solidFill>
                   <a:srgbClr val="5E6976"/>
                 </a:solidFill>
@@ -5978,19 +5978,19 @@
                 <a:ea typeface="Calibri" pitchFamily="34" charset="-122"/>
                 <a:cs typeface="Calibri" pitchFamily="34" charset="-120"/>
               </a:rPr>
-              <a:t>His loan is secured on the very thing he is concentrated in.</a:t>
-            </a:r>
-            <a:endParaRPr lang="en-US" sz="1650" dirty="0"/>
+              <a:t>Lau’s loan is secured on the very thing he is concentrated in,</a:t>
+            </a:r>
+            <a:endParaRPr lang="en-US" sz="1600" dirty="0"/>
           </a:p>
           <a:p>
             <a:pPr indent="0" marL="0">
               <a:lnSpc>
-                <a:spcPts val="2600"/>
+                <a:spcPts val="2500"/>
               </a:lnSpc>
               <a:buNone/>
             </a:pPr>
             <a:r>
-              <a:rPr lang="en-US" sz="1650" dirty="0">
+              <a:rPr lang="en-US" sz="1600" dirty="0">
                 <a:solidFill>
                   <a:srgbClr val="5E6976"/>
                 </a:solidFill>
@@ -5998,19 +5998,77 @@
                 <a:ea typeface="Calibri" pitchFamily="34" charset="-122"/>
                 <a:cs typeface="Calibri" pitchFamily="34" charset="-120"/>
               </a:rPr>
-              <a:t>So the usual remedy — sell something to raise cash — makes</a:t>
-            </a:r>
-            <a:endParaRPr lang="en-US" sz="1650" dirty="0"/>
-          </a:p>
-          <a:p>
-            <a:pPr indent="0" marL="0">
-              <a:lnSpc>
-                <a:spcPts val="2600"/>
-              </a:lnSpc>
-              <a:buNone/>
-            </a:pPr>
-            <a:r>
-              <a:rPr lang="en-US" sz="1650" dirty="0">
+              <a:t>so selling to raise cash makes the ratio worse, not better.</a:t>
+            </a:r>
+            <a:endParaRPr lang="en-US" sz="1600" dirty="0"/>
+          </a:p>
+        </p:txBody>
+      </p:sp>
+      <p:sp>
+        <p:nvSpPr>
+          <p:cNvPr id="5" name="Text 3"/>
+          <p:cNvSpPr txBox="1"/>
+          <p:nvPr/>
+        </p:nvSpPr>
+        <p:spPr>
+          <a:xfrm>
+            <a:off x="640080" y="2999232"/>
+            <a:ext cx="4572000" cy="274320"/>
+          </a:xfrm>
+          <a:prstGeom prst="rect">
+            <a:avLst/>
+          </a:prstGeom>
+          <a:noFill/>
+          <a:ln/>
+        </p:spPr>
+        <p:txBody>
+          <a:bodyPr wrap="square" lIns="0" tIns="0" rIns="0" bIns="0" rtlCol="0" anchor="ctr"/>
+          <a:lstStyle/>
+          <a:p>
+            <a:pPr indent="0" marL="0">
+              <a:buNone/>
+            </a:pPr>
+            <a:r>
+              <a:rPr lang="en-US" sz="1100" spc="200" kern="0" dirty="0">
+                <a:solidFill>
+                  <a:srgbClr val="2C6A4F"/>
+                </a:solidFill>
+                <a:latin typeface="Calibri" pitchFamily="34" charset="0"/>
+                <a:ea typeface="Calibri" pitchFamily="34" charset="-122"/>
+                <a:cs typeface="Calibri" pitchFamily="34" charset="-120"/>
+              </a:rPr>
+              <a:t>COMPUTED FROM HIS CREDIT FILE</a:t>
+            </a:r>
+            <a:endParaRPr lang="en-US" sz="1100" dirty="0"/>
+          </a:p>
+        </p:txBody>
+      </p:sp>
+      <p:sp>
+        <p:nvSpPr>
+          <p:cNvPr id="6" name="Text 4"/>
+          <p:cNvSpPr txBox="1"/>
+          <p:nvPr/>
+        </p:nvSpPr>
+        <p:spPr>
+          <a:xfrm>
+            <a:off x="640080" y="3401568"/>
+            <a:ext cx="1280160" cy="365760"/>
+          </a:xfrm>
+          <a:prstGeom prst="rect">
+            <a:avLst/>
+          </a:prstGeom>
+          <a:noFill/>
+          <a:ln/>
+        </p:spPr>
+        <p:txBody>
+          <a:bodyPr wrap="square" lIns="0" tIns="0" rIns="0" bIns="0" rtlCol="0" anchor="ctr"/>
+          <a:lstStyle/>
+          <a:p>
+            <a:pPr indent="0" marL="0">
+              <a:buNone/>
+            </a:pPr>
+            <a:r>
+              <a:rPr lang="en-US" sz="1600" dirty="0">
                 <a:solidFill>
                   <a:srgbClr val="5E6976"/>
                 </a:solidFill>
@@ -6018,45 +6076,6 @@
                 <a:ea typeface="Calibri" pitchFamily="34" charset="-122"/>
                 <a:cs typeface="Calibri" pitchFamily="34" charset="-120"/>
               </a:rPr>
-              <a:t>the ratio worse, not better.</a:t>
-            </a:r>
-            <a:endParaRPr lang="en-US" sz="1650" dirty="0"/>
-          </a:p>
-        </p:txBody>
-      </p:sp>
-      <p:sp>
-        <p:nvSpPr>
-          <p:cNvPr id="5" name="Text 3"/>
-          <p:cNvSpPr txBox="1"/>
-          <p:nvPr/>
-        </p:nvSpPr>
-        <p:spPr>
-          <a:xfrm>
-            <a:off x="640080" y="3291840"/>
-            <a:ext cx="1280160" cy="365760"/>
-          </a:xfrm>
-          <a:prstGeom prst="rect">
-            <a:avLst/>
-          </a:prstGeom>
-          <a:noFill/>
-          <a:ln/>
-        </p:spPr>
-        <p:txBody>
-          <a:bodyPr wrap="square" lIns="0" tIns="0" rIns="0" bIns="0" rtlCol="0" anchor="ctr"/>
-          <a:lstStyle/>
-          <a:p>
-            <a:pPr indent="0" marL="0">
-              <a:buNone/>
-            </a:pPr>
-            <a:r>
-              <a:rPr lang="en-US" sz="1600" dirty="0">
-                <a:solidFill>
-                  <a:srgbClr val="5E6976"/>
-                </a:solidFill>
-                <a:latin typeface="Calibri" pitchFamily="34" charset="0"/>
-                <a:ea typeface="Calibri" pitchFamily="34" charset="-122"/>
-                <a:cs typeface="Calibri" pitchFamily="34" charset="-120"/>
-              </a:rPr>
               <a:t>Today</a:t>
             </a:r>
             <a:endParaRPr lang="en-US" sz="1600" dirty="0"/>
@@ -6065,13 +6084,13 @@
       </p:sp>
       <p:sp>
         <p:nvSpPr>
-          <p:cNvPr id="6" name="Text 4"/>
-          <p:cNvSpPr txBox="1"/>
-          <p:nvPr/>
-        </p:nvSpPr>
-        <p:spPr>
-          <a:xfrm>
-            <a:off x="1874520" y="3236976"/>
+          <p:cNvPr id="7" name="Text 5"/>
+          <p:cNvSpPr txBox="1"/>
+          <p:nvPr/>
+        </p:nvSpPr>
+        <p:spPr>
+          <a:xfrm>
+            <a:off x="1874520" y="3346704"/>
             <a:ext cx="1645920" cy="457200"/>
           </a:xfrm>
           <a:prstGeom prst="rect">
@@ -6104,7 +6123,7 @@
       </p:sp>
       <p:sp>
         <p:nvSpPr>
-          <p:cNvPr id="7" name="Text 5"/>
+          <p:cNvPr id="8" name="Text 6"/>
           <p:cNvSpPr txBox="1"/>
           <p:nvPr/>
         </p:nvSpPr>
@@ -6143,7 +6162,7 @@
       </p:sp>
       <p:sp>
         <p:nvSpPr>
-          <p:cNvPr id="8" name="Text 6"/>
+          <p:cNvPr id="9" name="Text 7"/>
           <p:cNvSpPr txBox="1"/>
           <p:nvPr/>
         </p:nvSpPr>
@@ -6182,7 +6201,7 @@
       </p:sp>
       <p:sp>
         <p:nvSpPr>
-          <p:cNvPr id="9" name="Text 7"/>
+          <p:cNvPr id="10" name="Text 8"/>
           <p:cNvSpPr txBox="1"/>
           <p:nvPr/>
         </p:nvSpPr>
@@ -6221,13 +6240,13 @@
       </p:sp>
       <p:sp>
         <p:nvSpPr>
-          <p:cNvPr id="10" name="Text 8"/>
-          <p:cNvSpPr txBox="1"/>
-          <p:nvPr/>
-        </p:nvSpPr>
-        <p:spPr>
-          <a:xfrm>
-            <a:off x="640080" y="4608576"/>
+          <p:cNvPr id="11" name="Text 9"/>
+          <p:cNvSpPr txBox="1"/>
+          <p:nvPr/>
+        </p:nvSpPr>
+        <p:spPr>
+          <a:xfrm>
+            <a:off x="640080" y="4498848"/>
             <a:ext cx="1280160" cy="365760"/>
           </a:xfrm>
           <a:prstGeom prst="rect">
@@ -6260,13 +6279,13 @@
       </p:sp>
       <p:sp>
         <p:nvSpPr>
-          <p:cNvPr id="11" name="Text 9"/>
-          <p:cNvSpPr txBox="1"/>
-          <p:nvPr/>
-        </p:nvSpPr>
-        <p:spPr>
-          <a:xfrm>
-            <a:off x="1874520" y="4553712"/>
+          <p:cNvPr id="12" name="Text 10"/>
+          <p:cNvSpPr txBox="1"/>
+          <p:nvPr/>
+        </p:nvSpPr>
+        <p:spPr>
+          <a:xfrm>
+            <a:off x="1874520" y="4443984"/>
             <a:ext cx="1645920" cy="457200"/>
           </a:xfrm>
           <a:prstGeom prst="rect">
@@ -6299,13 +6318,13 @@
       </p:sp>
       <p:sp>
         <p:nvSpPr>
-          <p:cNvPr id="12" name="Text 10"/>
-          <p:cNvSpPr txBox="1"/>
-          <p:nvPr/>
-        </p:nvSpPr>
-        <p:spPr>
-          <a:xfrm>
-            <a:off x="3566160" y="4636008"/>
+          <p:cNvPr id="13" name="Text 11"/>
+          <p:cNvSpPr txBox="1"/>
+          <p:nvPr/>
+        </p:nvSpPr>
+        <p:spPr>
+          <a:xfrm>
+            <a:off x="3566160" y="4526280"/>
             <a:ext cx="1554480" cy="320040"/>
           </a:xfrm>
           <a:prstGeom prst="rect">
@@ -6338,13 +6357,13 @@
       </p:sp>
       <p:sp>
         <p:nvSpPr>
-          <p:cNvPr id="13" name="Text 11"/>
-          <p:cNvSpPr txBox="1"/>
-          <p:nvPr/>
-        </p:nvSpPr>
-        <p:spPr>
-          <a:xfrm>
-            <a:off x="640080" y="5266944"/>
+          <p:cNvPr id="14" name="Text 12"/>
+          <p:cNvSpPr txBox="1"/>
+          <p:nvPr/>
+        </p:nvSpPr>
+        <p:spPr>
+          <a:xfrm>
+            <a:off x="640080" y="5047488"/>
             <a:ext cx="1280160" cy="365760"/>
           </a:xfrm>
           <a:prstGeom prst="rect">
@@ -6377,13 +6396,13 @@
       </p:sp>
       <p:sp>
         <p:nvSpPr>
-          <p:cNvPr id="14" name="Text 12"/>
-          <p:cNvSpPr txBox="1"/>
-          <p:nvPr/>
-        </p:nvSpPr>
-        <p:spPr>
-          <a:xfrm>
-            <a:off x="1874520" y="5212080"/>
+          <p:cNvPr id="15" name="Text 13"/>
+          <p:cNvSpPr txBox="1"/>
+          <p:nvPr/>
+        </p:nvSpPr>
+        <p:spPr>
+          <a:xfrm>
+            <a:off x="1874520" y="4992624"/>
             <a:ext cx="1645920" cy="457200"/>
           </a:xfrm>
           <a:prstGeom prst="rect">
@@ -6416,13 +6435,13 @@
       </p:sp>
       <p:sp>
         <p:nvSpPr>
-          <p:cNvPr id="15" name="Text 13"/>
-          <p:cNvSpPr txBox="1"/>
-          <p:nvPr/>
-        </p:nvSpPr>
-        <p:spPr>
-          <a:xfrm>
-            <a:off x="3566160" y="5294376"/>
+          <p:cNvPr id="16" name="Text 14"/>
+          <p:cNvSpPr txBox="1"/>
+          <p:nvPr/>
+        </p:nvSpPr>
+        <p:spPr>
+          <a:xfrm>
+            <a:off x="3566160" y="5074920"/>
             <a:ext cx="1554480" cy="320040"/>
           </a:xfrm>
           <a:prstGeom prst="rect">
@@ -6455,7 +6474,7 @@
       </p:sp>
       <p:pic>
         <p:nvPicPr>
-          <p:cNvPr id="16" name="Image 0" descr="screens/c-outlook.png">    </p:cNvPr>
+          <p:cNvPr id="17" name="Image 0" descr="screens/c-simulator.png">    </p:cNvPr>
           <p:cNvPicPr>
             <a:picLocks noChangeAspect="1"/>
           </p:cNvPicPr>
@@ -6469,8 +6488,8 @@
         </p:blipFill>
         <p:spPr>
           <a:xfrm>
-            <a:off x="5623560" y="1737360"/>
-            <a:ext cx="5943600" cy="2642616"/>
+            <a:off x="5623560" y="1691640"/>
+            <a:ext cx="5943600" cy="2724912"/>
           </a:xfrm>
           <a:prstGeom prst="rect">
             <a:avLst/>
@@ -6479,30 +6498,30 @@
       </p:pic>
       <p:sp>
         <p:nvSpPr>
-          <p:cNvPr id="17" name="Text 14"/>
+          <p:cNvPr id="18" name="Text 15"/>
           <p:cNvSpPr txBox="1"/>
           <p:nvPr/>
         </p:nvSpPr>
         <p:spPr>
           <a:xfrm>
             <a:off x="5623560" y="4572000"/>
-            <a:ext cx="5943600" cy="365760"/>
-          </a:xfrm>
-          <a:prstGeom prst="rect">
-            <a:avLst/>
-          </a:prstGeom>
-          <a:noFill/>
-          <a:ln/>
-        </p:spPr>
-        <p:txBody>
-          <a:bodyPr wrap="square" lIns="0" tIns="0" rIns="0" bIns="0" rtlCol="0" anchor="ctr"/>
-          <a:lstStyle/>
-          <a:p>
-            <a:pPr indent="0" marL="0">
-              <a:buNone/>
-            </a:pPr>
-            <a:r>
-              <a:rPr lang="en-US" sz="1450" spc="100" kern="0" dirty="0">
+            <a:ext cx="5943600" cy="274320"/>
+          </a:xfrm>
+          <a:prstGeom prst="rect">
+            <a:avLst/>
+          </a:prstGeom>
+          <a:noFill/>
+          <a:ln/>
+        </p:spPr>
+        <p:txBody>
+          <a:bodyPr wrap="square" lIns="0" tIns="0" rIns="0" bIns="0" rtlCol="0" anchor="ctr"/>
+          <a:lstStyle/>
+          <a:p>
+            <a:pPr indent="0" marL="0">
+              <a:buNone/>
+            </a:pPr>
+            <a:r>
+              <a:rPr lang="en-US" sz="1100" spc="200" kern="0" dirty="0">
                 <a:solidFill>
                   <a:srgbClr val="A68430"/>
                 </a:solidFill>
@@ -6510,9 +6529,90 @@
                 <a:ea typeface="Calibri" pitchFamily="34" charset="-122"/>
                 <a:cs typeface="Calibri" pitchFamily="34" charset="-120"/>
               </a:rPr>
-              <a:t>Computed from real lending values — not typed in.</a:t>
-            </a:r>
-            <a:endParaRPr lang="en-US" sz="1450" dirty="0"/>
+              <a:t>AND THE SAME SHOCK ACROSS ALL TWENTY</a:t>
+            </a:r>
+            <a:endParaRPr lang="en-US" sz="1100" dirty="0"/>
+          </a:p>
+        </p:txBody>
+      </p:sp>
+      <p:sp>
+        <p:nvSpPr>
+          <p:cNvPr id="19" name="Text 16"/>
+          <p:cNvSpPr txBox="1"/>
+          <p:nvPr/>
+        </p:nvSpPr>
+        <p:spPr>
+          <a:xfrm>
+            <a:off x="5623560" y="4892040"/>
+            <a:ext cx="5943600" cy="822960"/>
+          </a:xfrm>
+          <a:prstGeom prst="rect">
+            <a:avLst/>
+          </a:prstGeom>
+          <a:noFill/>
+          <a:ln/>
+        </p:spPr>
+        <p:txBody>
+          <a:bodyPr wrap="square" lIns="0" tIns="0" rIns="0" bIns="0" rtlCol="0" anchor="ctr"/>
+          <a:lstStyle/>
+          <a:p>
+            <a:pPr indent="0" marL="0">
+              <a:lnSpc>
+                <a:spcPts val="2200"/>
+              </a:lnSpc>
+              <a:buNone/>
+            </a:pPr>
+            <a:r>
+              <a:rPr lang="en-US" sz="1400" dirty="0">
+                <a:solidFill>
+                  <a:srgbClr val="5E6976"/>
+                </a:solidFill>
+                <a:latin typeface="Calibri" pitchFamily="34" charset="0"/>
+                <a:ea typeface="Calibri" pitchFamily="34" charset="-122"/>
+                <a:cs typeface="Calibri" pitchFamily="34" charset="-120"/>
+              </a:rPr>
+              <a:t>Four macro scenarios re-rank the book in place. Selecting a Middle East oil shock moves Lau to the top of Priscilla’s list, and Elena with him on commodities.</a:t>
+            </a:r>
+            <a:endParaRPr lang="en-US" sz="1400" dirty="0"/>
+          </a:p>
+        </p:txBody>
+      </p:sp>
+      <p:sp>
+        <p:nvSpPr>
+          <p:cNvPr id="20" name="Text 17"/>
+          <p:cNvSpPr txBox="1"/>
+          <p:nvPr/>
+        </p:nvSpPr>
+        <p:spPr>
+          <a:xfrm>
+            <a:off x="640080" y="6355080"/>
+            <a:ext cx="10881360" cy="274320"/>
+          </a:xfrm>
+          <a:prstGeom prst="rect">
+            <a:avLst/>
+          </a:prstGeom>
+          <a:noFill/>
+          <a:ln/>
+        </p:spPr>
+        <p:txBody>
+          <a:bodyPr wrap="square" lIns="0" tIns="0" rIns="0" bIns="0" rtlCol="0" anchor="ctr"/>
+          <a:lstStyle/>
+          <a:p>
+            <a:pPr indent="0" marL="0">
+              <a:buNone/>
+            </a:pPr>
+            <a:r>
+              <a:rPr lang="en-US" sz="1150" dirty="0">
+                <a:solidFill>
+                  <a:srgbClr val="8B96A3"/>
+                </a:solidFill>
+                <a:latin typeface="Calibri" pitchFamily="34" charset="0"/>
+                <a:ea typeface="Calibri" pitchFamily="34" charset="-122"/>
+                <a:cs typeface="Calibri" pitchFamily="34" charset="-120"/>
+              </a:rPr>
+              <a:t>Left: loan-to-value computed from the credit facility under collateral shocks. Right: scenario definitions are ours; every figure quoted inside them is read from the dataset</a:t>
+            </a:r>
+            <a:endParaRPr lang="en-US" sz="1150" dirty="0"/>
           </a:p>
         </p:txBody>
       </p:sp>

</xml_diff>

<commit_message>
deck: make the consent screen prominent on 11, give 12 a stat band
Slide 11: the Briefing Recorder consent modal was a 1.03in thumbnail nobody
could read. Recropped it to the modal itself (screens/c-consent.png) and
made it the left column at 3.25in wide; the LIVE TODAY / NEXT cards move to
a single right-hand column. The punchline about feeding the meeting back
into the next conversation is promoted to the lede.

Slide 12: was flat left-aligned text with an empty right half. Keeps the
three closing beats, adds a gold rule and a four-number band underneath —
7 of 20, 6 held, 48 findings, USD 8.50m idle. Every figure is read from
/api/book, not asserted. Repo link enlarged and given room.

Co-Authored-By: Claude Opus 5 <noreply@anthropic.com>
</commit_message>
<xml_diff>
--- a/docs/Foresight-RM-Pitch.pptx
+++ b/docs/Foresight-RM-Pitch.pptx
@@ -777,7 +777,7 @@
           <a:p>
             <a:r>
               <a:rPr lang="en-US" dirty="0"/>
-              <a:t>Close on these three sentences, then move to the demonstration.</a:t>
+              <a:t>Close on the three sentences, then let the four numbers sit on screen through questions. Every one of them is read from the run, not asserted: seven of twenty clients had an RM note change the answer, six findings were held with a reason and a revisit date, forty-eight findings came from six agents, and USD 8.50m of idle cash sits above mandate.</a:t>
             </a:r>
             <a:endParaRPr lang="en-US" dirty="0"/>
           </a:p>
@@ -2523,8 +2523,8 @@
         </p:nvSpPr>
         <p:spPr>
           <a:xfrm>
-            <a:off x="640080" y="1783080"/>
-            <a:ext cx="10881360" cy="731520"/>
+            <a:off x="640080" y="1737360"/>
+            <a:ext cx="10881360" cy="594360"/>
           </a:xfrm>
           <a:prstGeom prst="rect">
             <a:avLst/>
@@ -2538,39 +2538,102 @@
           <a:p>
             <a:pPr indent="0" marL="0">
               <a:lnSpc>
-                <a:spcPts val="2400"/>
+                <a:spcPts val="2600"/>
               </a:lnSpc>
               <a:buNone/>
             </a:pPr>
             <a:r>
-              <a:rPr lang="en-US" sz="1600" dirty="0">
-                <a:solidFill>
-                  <a:srgbClr val="5E6976"/>
-                </a:solidFill>
-                <a:latin typeface="Calibri" pitchFamily="34" charset="0"/>
-                <a:ea typeface="Calibri" pitchFamily="34" charset="-122"/>
-                <a:cs typeface="Calibri" pitchFamily="34" charset="-120"/>
-              </a:rPr>
-              <a:t>The tone analysis already runs. Today it reads the twenty-eight written RM notes and produces the guidance below. Point the same pipeline at a consented meeting transcript and it reads the room instead.</a:t>
-            </a:r>
-            <a:endParaRPr lang="en-US" sz="1600" dirty="0"/>
-          </a:p>
-        </p:txBody>
-      </p:sp>
-      <p:sp>
-        <p:nvSpPr>
-          <p:cNvPr id="6" name="Shape 3"/>
+              <a:rPr lang="en-US" sz="1800" dirty="0">
+                <a:solidFill>
+                  <a:srgbClr val="141E55"/>
+                </a:solidFill>
+                <a:latin typeface="Calibri" pitchFamily="34" charset="0"/>
+                <a:ea typeface="Calibri" pitchFamily="34" charset="-122"/>
+                <a:cs typeface="Calibri" pitchFamily="34" charset="-120"/>
+              </a:rPr>
+              <a:t>Every other tool summarises the meeting and files a note. Ours feeds what was said back into what may be said next.</a:t>
+            </a:r>
+            <a:endParaRPr lang="en-US" sz="1800" dirty="0"/>
+          </a:p>
+        </p:txBody>
+      </p:sp>
+      <p:sp>
+        <p:nvSpPr>
+          <p:cNvPr id="6" name="Text 3"/>
+          <p:cNvSpPr txBox="1"/>
+          <p:nvPr/>
+        </p:nvSpPr>
+        <p:spPr>
+          <a:xfrm>
+            <a:off x="640080" y="2514600"/>
+            <a:ext cx="3383280" cy="274320"/>
+          </a:xfrm>
+          <a:prstGeom prst="rect">
+            <a:avLst/>
+          </a:prstGeom>
+          <a:noFill/>
+          <a:ln/>
+        </p:spPr>
+        <p:txBody>
+          <a:bodyPr wrap="square" lIns="0" tIns="0" rIns="0" bIns="0" rtlCol="0" anchor="ctr"/>
+          <a:lstStyle/>
+          <a:p>
+            <a:pPr indent="0" marL="0">
+              <a:buNone/>
+            </a:pPr>
+            <a:r>
+              <a:rPr lang="en-US" sz="1100" spc="160" kern="0" dirty="0">
+                <a:solidFill>
+                  <a:srgbClr val="2C6A4F"/>
+                </a:solidFill>
+                <a:latin typeface="Calibri" pitchFamily="34" charset="0"/>
+                <a:ea typeface="Calibri" pitchFamily="34" charset="-122"/>
+                <a:cs typeface="Calibri" pitchFamily="34" charset="-120"/>
+              </a:rPr>
+              <a:t>BUILT TODAY · CONSENT BEFORE RECORDING</a:t>
+            </a:r>
+            <a:endParaRPr lang="en-US" sz="1100" dirty="0"/>
+          </a:p>
+        </p:txBody>
+      </p:sp>
+      <p:pic>
+        <p:nvPicPr>
+          <p:cNvPr id="7" name="Image 1" descr="screens/c-consent.png">    </p:cNvPr>
+          <p:cNvPicPr>
+            <a:picLocks noChangeAspect="1"/>
+          </p:cNvPicPr>
+          <p:nvPr/>
+        </p:nvPicPr>
+        <p:blipFill>
+          <a:blip r:embed="rId2"/>
+          <a:stretch>
+            <a:fillRect/>
+          </a:stretch>
+        </p:blipFill>
+        <p:spPr>
+          <a:xfrm>
+            <a:off x="640080" y="2788920"/>
+            <a:ext cx="2971800" cy="3337560"/>
+          </a:xfrm>
+          <a:prstGeom prst="rect">
+            <a:avLst/>
+          </a:prstGeom>
+        </p:spPr>
+      </p:pic>
+      <p:sp>
+        <p:nvSpPr>
+          <p:cNvPr id="8" name="Shape 4"/>
           <p:cNvSpPr/>
           <p:nvPr/>
         </p:nvSpPr>
         <p:spPr>
           <a:xfrm>
-            <a:off x="640080" y="2697480"/>
-            <a:ext cx="5349240" cy="2148840"/>
+            <a:off x="4114800" y="2514600"/>
+            <a:ext cx="7434072" cy="1737360"/>
           </a:xfrm>
           <a:prstGeom prst="roundRect">
             <a:avLst>
-              <a:gd name="adj" fmla="val 2553"/>
+              <a:gd name="adj" fmla="val 3158"/>
             </a:avLst>
           </a:prstGeom>
           <a:solidFill>
@@ -2586,14 +2649,14 @@
       </p:sp>
       <p:sp>
         <p:nvSpPr>
-          <p:cNvPr id="7" name="Text 4"/>
-          <p:cNvSpPr txBox="1"/>
-          <p:nvPr/>
-        </p:nvSpPr>
-        <p:spPr>
-          <a:xfrm>
-            <a:off x="914400" y="2880360"/>
-            <a:ext cx="4846320" cy="274320"/>
+          <p:cNvPr id="9" name="Text 5"/>
+          <p:cNvSpPr txBox="1"/>
+          <p:nvPr/>
+        </p:nvSpPr>
+        <p:spPr>
+          <a:xfrm>
+            <a:off x="4434840" y="2724912"/>
+            <a:ext cx="6858000" cy="274320"/>
           </a:xfrm>
           <a:prstGeom prst="rect">
             <a:avLst/>
@@ -2617,7 +2680,7 @@
                 <a:ea typeface="Calibri" pitchFamily="34" charset="-122"/>
                 <a:cs typeface="Calibri" pitchFamily="34" charset="-120"/>
               </a:rPr>
-              <a:t>LIVE TODAY  ·  FROM WRITTEN NOTES</a:t>
+              <a:t>LIVE TODAY  ·  FROM THE 28 WRITTEN RM NOTES</a:t>
             </a:r>
             <a:endParaRPr lang="en-US" sz="1250" dirty="0"/>
           </a:p>
@@ -2625,14 +2688,14 @@
       </p:sp>
       <p:sp>
         <p:nvSpPr>
-          <p:cNvPr id="8" name="Text 5"/>
-          <p:cNvSpPr txBox="1"/>
-          <p:nvPr/>
-        </p:nvSpPr>
-        <p:spPr>
-          <a:xfrm>
-            <a:off x="914400" y="3246120"/>
-            <a:ext cx="4846320" cy="1371600"/>
+          <p:cNvPr id="10" name="Text 6"/>
+          <p:cNvSpPr txBox="1"/>
+          <p:nvPr/>
+        </p:nvSpPr>
+        <p:spPr>
+          <a:xfrm>
+            <a:off x="4434840" y="3108960"/>
+            <a:ext cx="6858000" cy="960120"/>
           </a:xfrm>
           <a:prstGeom prst="rect">
             <a:avLst/>
@@ -2646,7 +2709,7 @@
           <a:p>
             <a:pPr indent="0" marL="0">
               <a:lnSpc>
-                <a:spcPts val="2200"/>
+                <a:spcPts val="2300"/>
               </a:lnSpc>
               <a:buNone/>
             </a:pPr>
@@ -2667,18 +2730,18 @@
       </p:sp>
       <p:sp>
         <p:nvSpPr>
-          <p:cNvPr id="9" name="Shape 6"/>
+          <p:cNvPr id="11" name="Shape 7"/>
           <p:cNvSpPr/>
           <p:nvPr/>
         </p:nvSpPr>
         <p:spPr>
           <a:xfrm>
-            <a:off x="6172200" y="2697480"/>
-            <a:ext cx="5349240" cy="2148840"/>
+            <a:off x="4114800" y="4389120"/>
+            <a:ext cx="7434072" cy="1737360"/>
           </a:xfrm>
           <a:prstGeom prst="roundRect">
             <a:avLst>
-              <a:gd name="adj" fmla="val 2553"/>
+              <a:gd name="adj" fmla="val 3158"/>
             </a:avLst>
           </a:prstGeom>
           <a:solidFill>
@@ -2694,14 +2757,14 @@
       </p:sp>
       <p:sp>
         <p:nvSpPr>
-          <p:cNvPr id="10" name="Text 7"/>
-          <p:cNvSpPr txBox="1"/>
-          <p:nvPr/>
-        </p:nvSpPr>
-        <p:spPr>
-          <a:xfrm>
-            <a:off x="6446520" y="2880360"/>
-            <a:ext cx="4846320" cy="274320"/>
+          <p:cNvPr id="12" name="Text 8"/>
+          <p:cNvSpPr txBox="1"/>
+          <p:nvPr/>
+        </p:nvSpPr>
+        <p:spPr>
+          <a:xfrm>
+            <a:off x="4434840" y="4599432"/>
+            <a:ext cx="6858000" cy="274320"/>
           </a:xfrm>
           <a:prstGeom prst="rect">
             <a:avLst/>
@@ -2733,14 +2796,14 @@
       </p:sp>
       <p:sp>
         <p:nvSpPr>
-          <p:cNvPr id="11" name="Text 8"/>
-          <p:cNvSpPr txBox="1"/>
-          <p:nvPr/>
-        </p:nvSpPr>
-        <p:spPr>
-          <a:xfrm>
-            <a:off x="6537960" y="3246120"/>
-            <a:ext cx="4709160" cy="1371600"/>
+          <p:cNvPr id="13" name="Text 9"/>
+          <p:cNvSpPr txBox="1"/>
+          <p:nvPr/>
+        </p:nvSpPr>
+        <p:spPr>
+          <a:xfrm>
+            <a:off x="4572000" y="4983480"/>
+            <a:ext cx="6675120" cy="1005840"/>
           </a:xfrm>
           <a:prstGeom prst="rect">
             <a:avLst/>
@@ -2753,14 +2816,17 @@
           <a:lstStyle/>
           <a:p>
             <a:pPr marL="342900" indent="-342900">
+              <a:lnSpc>
+                <a:spcPts val="1900"/>
+              </a:lnSpc>
               <a:spcAft>
-                <a:spcPts val="700"/>
+                <a:spcPts val="500"/>
               </a:spcAft>
               <a:buSzPct val="100000"/>
               <a:buChar char="•"/>
             </a:pPr>
             <a:r>
-              <a:rPr lang="en-US" sz="1250" dirty="0">
+              <a:rPr lang="en-US" sz="1300" dirty="0">
                 <a:solidFill>
                   <a:srgbClr val="5E6976"/>
                 </a:solidFill>
@@ -2770,18 +2836,21 @@
               </a:rPr>
               <a:t>Consent captured before anything records.</a:t>
             </a:r>
-            <a:endParaRPr lang="en-US" sz="1250" dirty="0"/>
+            <a:endParaRPr lang="en-US" sz="1300" dirty="0"/>
           </a:p>
           <a:p>
             <a:pPr marL="342900" indent="-342900">
+              <a:lnSpc>
+                <a:spcPts val="1900"/>
+              </a:lnSpc>
               <a:spcAft>
-                <a:spcPts val="700"/>
+                <a:spcPts val="500"/>
               </a:spcAft>
               <a:buSzPct val="100000"/>
               <a:buChar char="•"/>
             </a:pPr>
             <a:r>
-              <a:rPr lang="en-US" sz="1250" dirty="0">
+              <a:rPr lang="en-US" sz="1300" dirty="0">
                 <a:solidFill>
                   <a:srgbClr val="5E6976"/>
                 </a:solidFill>
@@ -2791,18 +2860,21 @@
               </a:rPr>
               <a:t>Tone and concerns extracted from the meeting.</a:t>
             </a:r>
-            <a:endParaRPr lang="en-US" sz="1250" dirty="0"/>
+            <a:endParaRPr lang="en-US" sz="1300" dirty="0"/>
           </a:p>
           <a:p>
             <a:pPr marL="342900" indent="-342900">
+              <a:lnSpc>
+                <a:spcPts val="1900"/>
+              </a:lnSpc>
               <a:spcAft>
-                <a:spcPts val="700"/>
+                <a:spcPts val="500"/>
               </a:spcAft>
               <a:buSzPct val="100000"/>
               <a:buChar char="•"/>
             </a:pPr>
             <a:r>
-              <a:rPr lang="en-US" sz="1250" dirty="0">
+              <a:rPr lang="en-US" sz="1300" dirty="0">
                 <a:solidFill>
                   <a:srgbClr val="5E6976"/>
                 </a:solidFill>
@@ -2810,163 +2882,15 @@
                 <a:ea typeface="Calibri" pitchFamily="34" charset="-122"/>
                 <a:cs typeface="Calibri" pitchFamily="34" charset="-120"/>
               </a:rPr>
-              <a:t>Those become constraints — so the gate holds a</a:t>
-            </a:r>
-            <a:endParaRPr lang="en-US" sz="1250" dirty="0"/>
-          </a:p>
-          <a:p>
-            <a:pPr indent="0" marL="0">
-              <a:spcAft>
-                <a:spcPts val="700"/>
-              </a:spcAft>
-              <a:buNone/>
-            </a:pPr>
-            <a:r>
-              <a:rPr lang="en-US" sz="1250" dirty="0">
-                <a:solidFill>
-                  <a:srgbClr val="5E6976"/>
-                </a:solidFill>
-                <a:latin typeface="Calibri" pitchFamily="34" charset="0"/>
-                <a:ea typeface="Calibri" pitchFamily="34" charset="-122"/>
-                <a:cs typeface="Calibri" pitchFamily="34" charset="-120"/>
-              </a:rPr>
-              <a:t>    recommendation the client is not ready to hear.</a:t>
-            </a:r>
-            <a:endParaRPr lang="en-US" sz="1250" dirty="0"/>
-          </a:p>
-        </p:txBody>
-      </p:sp>
-      <p:pic>
-        <p:nvPicPr>
-          <p:cNvPr id="12" name="Image 1" descr="screens/c-recorder.png">    </p:cNvPr>
-          <p:cNvPicPr>
-            <a:picLocks noChangeAspect="1"/>
-          </p:cNvPicPr>
-          <p:nvPr/>
-        </p:nvPicPr>
-        <p:blipFill>
-          <a:blip r:embed="rId2"/>
-          <a:stretch>
-            <a:fillRect/>
-          </a:stretch>
-        </p:blipFill>
-        <p:spPr>
-          <a:xfrm>
-            <a:off x="640080" y="5029200"/>
-            <a:ext cx="941832" cy="1188720"/>
-          </a:xfrm>
-          <a:prstGeom prst="rect">
-            <a:avLst/>
-          </a:prstGeom>
-        </p:spPr>
-      </p:pic>
-      <p:sp>
-        <p:nvSpPr>
-          <p:cNvPr id="13" name="Text 9"/>
-          <p:cNvSpPr txBox="1"/>
-          <p:nvPr/>
-        </p:nvSpPr>
-        <p:spPr>
-          <a:xfrm>
-            <a:off x="1783080" y="5074920"/>
-            <a:ext cx="4023360" cy="548640"/>
-          </a:xfrm>
-          <a:prstGeom prst="rect">
-            <a:avLst/>
-          </a:prstGeom>
-          <a:noFill/>
-          <a:ln/>
-        </p:spPr>
-        <p:txBody>
-          <a:bodyPr wrap="square" lIns="0" tIns="0" rIns="0" bIns="0" rtlCol="0" anchor="ctr"/>
-          <a:lstStyle/>
-          <a:p>
-            <a:pPr indent="0" marL="0">
-              <a:lnSpc>
-                <a:spcPts val="2000"/>
-              </a:lnSpc>
-              <a:buNone/>
-            </a:pPr>
-            <a:r>
-              <a:rPr lang="en-US" sz="1350" dirty="0">
-                <a:solidFill>
-                  <a:srgbClr val="5E6976"/>
-                </a:solidFill>
-                <a:latin typeface="Calibri" pitchFamily="34" charset="0"/>
-                <a:ea typeface="Calibri" pitchFamily="34" charset="-122"/>
-                <a:cs typeface="Calibri" pitchFamily="34" charset="-120"/>
-              </a:rPr>
-              <a:t>Consent is captured and logged before the microphone opens.</a:t>
-            </a:r>
-            <a:endParaRPr lang="en-US" sz="1350" dirty="0"/>
+              <a:t>Those become constraints — so the gate holds a recommendation the client is not ready to hear.</a:t>
+            </a:r>
+            <a:endParaRPr lang="en-US" sz="1300" dirty="0"/>
           </a:p>
         </p:txBody>
       </p:sp>
       <p:sp>
         <p:nvSpPr>
           <p:cNvPr id="14" name="Text 10"/>
-          <p:cNvSpPr txBox="1"/>
-          <p:nvPr/>
-        </p:nvSpPr>
-        <p:spPr>
-          <a:xfrm>
-            <a:off x="6035040" y="5029200"/>
-            <a:ext cx="5486400" cy="914400"/>
-          </a:xfrm>
-          <a:prstGeom prst="rect">
-            <a:avLst/>
-          </a:prstGeom>
-          <a:noFill/>
-          <a:ln/>
-        </p:spPr>
-        <p:txBody>
-          <a:bodyPr wrap="square" lIns="0" tIns="0" rIns="0" bIns="0" rtlCol="0" anchor="ctr"/>
-          <a:lstStyle/>
-          <a:p>
-            <a:pPr indent="0" marL="0">
-              <a:lnSpc>
-                <a:spcPts val="2600"/>
-              </a:lnSpc>
-              <a:buNone/>
-            </a:pPr>
-            <a:r>
-              <a:rPr lang="en-US" sz="1650" dirty="0">
-                <a:solidFill>
-                  <a:srgbClr val="141E55"/>
-                </a:solidFill>
-                <a:latin typeface="Calibri" pitchFamily="34" charset="0"/>
-                <a:ea typeface="Calibri" pitchFamily="34" charset="-122"/>
-                <a:cs typeface="Calibri" pitchFamily="34" charset="-120"/>
-              </a:rPr>
-              <a:t>Every other tool summarises the meeting and files a note.</a:t>
-            </a:r>
-            <a:endParaRPr lang="en-US" sz="1650" dirty="0"/>
-          </a:p>
-          <a:p>
-            <a:pPr indent="0" marL="0">
-              <a:lnSpc>
-                <a:spcPts val="2600"/>
-              </a:lnSpc>
-              <a:buNone/>
-            </a:pPr>
-            <a:r>
-              <a:rPr lang="en-US" sz="1650" dirty="0">
-                <a:solidFill>
-                  <a:srgbClr val="141E55"/>
-                </a:solidFill>
-                <a:latin typeface="Calibri" pitchFamily="34" charset="0"/>
-                <a:ea typeface="Calibri" pitchFamily="34" charset="-122"/>
-                <a:cs typeface="Calibri" pitchFamily="34" charset="-120"/>
-              </a:rPr>
-              <a:t>Ours feeds what was said back into what may be said next.</a:t>
-            </a:r>
-            <a:endParaRPr lang="en-US" sz="1650" dirty="0"/>
-          </a:p>
-        </p:txBody>
-      </p:sp>
-      <p:sp>
-        <p:nvSpPr>
-          <p:cNvPr id="15" name="Text 11"/>
           <p:cNvSpPr txBox="1"/>
           <p:nvPr/>
         </p:nvSpPr>
@@ -2997,7 +2921,7 @@
                 <a:ea typeface="Calibri" pitchFamily="34" charset="-122"/>
                 <a:cs typeface="Calibri" pitchFamily="34" charset="-120"/>
               </a:rPr>
-              <a:t>No transcript exists in the supplied dataset, so none was fabricated — the analysis runs on the real notes instead</a:t>
+              <a:t>The tone analysis runs live on the written notes. No transcript exists in the supplied dataset, so none was fabricated</a:t>
             </a:r>
             <a:endParaRPr lang="en-US" sz="1150" dirty="0"/>
           </a:p>
@@ -3043,7 +2967,7 @@
         </p:nvSpPr>
         <p:spPr>
           <a:xfrm>
-            <a:off x="822960" y="685800"/>
+            <a:off x="822960" y="640080"/>
             <a:ext cx="8229600" cy="256032"/>
           </a:xfrm>
           <a:prstGeom prst="rect">
@@ -3082,8 +3006,8 @@
         </p:nvSpPr>
         <p:spPr>
           <a:xfrm>
-            <a:off x="822960" y="1691640"/>
-            <a:ext cx="10515600" cy="3291840"/>
+            <a:off x="822960" y="1325880"/>
+            <a:ext cx="10515600" cy="960120"/>
           </a:xfrm>
           <a:prstGeom prst="rect">
             <a:avLst/>
@@ -3097,12 +3021,12 @@
           <a:p>
             <a:pPr indent="0" marL="0">
               <a:lnSpc>
-                <a:spcPts val="4000"/>
+                <a:spcPts val="3600"/>
               </a:lnSpc>
               <a:buNone/>
             </a:pPr>
             <a:r>
-              <a:rPr lang="en-US" sz="2500" dirty="0">
+              <a:rPr lang="en-US" sz="2400" dirty="0">
                 <a:solidFill>
                   <a:srgbClr val="FFFFFF"/>
                 </a:solidFill>
@@ -3112,17 +3036,17 @@
               </a:rPr>
               <a:t>Lau’s flat, shares, bond, derivative, job and loan are one bet —</a:t>
             </a:r>
-            <a:endParaRPr lang="en-US" sz="2500" dirty="0"/>
+            <a:endParaRPr lang="en-US" sz="2400" dirty="0"/>
           </a:p>
           <a:p>
             <a:pPr indent="0" marL="0">
               <a:lnSpc>
-                <a:spcPts val="4000"/>
+                <a:spcPts val="3600"/>
               </a:lnSpc>
               <a:buNone/>
             </a:pPr>
             <a:r>
-              <a:rPr lang="en-US" sz="2500" dirty="0">
+              <a:rPr lang="en-US" sz="2400" dirty="0">
                 <a:solidFill>
                   <a:srgbClr val="FFFFFF"/>
                 </a:solidFill>
@@ -3132,17 +3056,39 @@
               </a:rPr>
               <a:t>and no system in the bank could see it.</a:t>
             </a:r>
-            <a:endParaRPr lang="en-US" sz="2500" dirty="0"/>
-          </a:p>
+            <a:endParaRPr lang="en-US" sz="2400" dirty="0"/>
+          </a:p>
+        </p:txBody>
+      </p:sp>
+      <p:sp>
+        <p:nvSpPr>
+          <p:cNvPr id="4" name="Text 2"/>
+          <p:cNvSpPr txBox="1"/>
+          <p:nvPr/>
+        </p:nvSpPr>
+        <p:spPr>
+          <a:xfrm>
+            <a:off x="822960" y="2487168"/>
+            <a:ext cx="10515600" cy="960120"/>
+          </a:xfrm>
+          <a:prstGeom prst="rect">
+            <a:avLst/>
+          </a:prstGeom>
+          <a:noFill/>
+          <a:ln/>
+        </p:spPr>
+        <p:txBody>
+          <a:bodyPr wrap="square" lIns="0" tIns="0" rIns="0" bIns="0" rtlCol="0" anchor="ctr"/>
+          <a:lstStyle/>
           <a:p>
             <a:pPr indent="0" marL="0">
               <a:lnSpc>
-                <a:spcPts val="4000"/>
+                <a:spcPts val="3600"/>
               </a:lnSpc>
               <a:buNone/>
             </a:pPr>
             <a:r>
-              <a:rPr lang="en-US" sz="2500" dirty="0">
+              <a:rPr lang="en-US" sz="2400" dirty="0">
                 <a:solidFill>
                   <a:srgbClr val="FFFFFF"/>
                 </a:solidFill>
@@ -3150,19 +3096,19 @@
                 <a:ea typeface="Calibri" pitchFamily="34" charset="-122"/>
                 <a:cs typeface="Calibri" pitchFamily="34" charset="-120"/>
               </a:rPr>
-              <a:t> </a:t>
-            </a:r>
-            <a:endParaRPr lang="en-US" sz="2500" dirty="0"/>
+              <a:t>Priscilla worked it out in March and typed it into a note.</a:t>
+            </a:r>
+            <a:endParaRPr lang="en-US" sz="2400" dirty="0"/>
           </a:p>
           <a:p>
             <a:pPr indent="0" marL="0">
               <a:lnSpc>
-                <a:spcPts val="4000"/>
+                <a:spcPts val="3600"/>
               </a:lnSpc>
               <a:buNone/>
             </a:pPr>
             <a:r>
-              <a:rPr lang="en-US" sz="2500" dirty="0">
+              <a:rPr lang="en-US" sz="2400" dirty="0">
                 <a:solidFill>
                   <a:srgbClr val="FFFFFF"/>
                 </a:solidFill>
@@ -3170,19 +3116,41 @@
                 <a:ea typeface="Calibri" pitchFamily="34" charset="-122"/>
                 <a:cs typeface="Calibri" pitchFamily="34" charset="-120"/>
               </a:rPr>
-              <a:t>Priscilla worked it out in March and typed it into a note.</a:t>
-            </a:r>
-            <a:endParaRPr lang="en-US" sz="2500" dirty="0"/>
-          </a:p>
+              <a:t>Nothing read it.</a:t>
+            </a:r>
+            <a:endParaRPr lang="en-US" sz="2400" dirty="0"/>
+          </a:p>
+        </p:txBody>
+      </p:sp>
+      <p:sp>
+        <p:nvSpPr>
+          <p:cNvPr id="5" name="Text 3"/>
+          <p:cNvSpPr txBox="1"/>
+          <p:nvPr/>
+        </p:nvSpPr>
+        <p:spPr>
+          <a:xfrm>
+            <a:off x="822960" y="3648456"/>
+            <a:ext cx="10515600" cy="960120"/>
+          </a:xfrm>
+          <a:prstGeom prst="rect">
+            <a:avLst/>
+          </a:prstGeom>
+          <a:noFill/>
+          <a:ln/>
+        </p:spPr>
+        <p:txBody>
+          <a:bodyPr wrap="square" lIns="0" tIns="0" rIns="0" bIns="0" rtlCol="0" anchor="ctr"/>
+          <a:lstStyle/>
           <a:p>
             <a:pPr indent="0" marL="0">
               <a:lnSpc>
-                <a:spcPts val="4000"/>
+                <a:spcPts val="3600"/>
               </a:lnSpc>
               <a:buNone/>
             </a:pPr>
             <a:r>
-              <a:rPr lang="en-US" sz="2500" dirty="0">
+              <a:rPr lang="en-US" sz="2400" dirty="0">
                 <a:solidFill>
                   <a:srgbClr val="FFFFFF"/>
                 </a:solidFill>
@@ -3190,19 +3158,19 @@
                 <a:ea typeface="Calibri" pitchFamily="34" charset="-122"/>
                 <a:cs typeface="Calibri" pitchFamily="34" charset="-120"/>
               </a:rPr>
-              <a:t>Nothing read it.</a:t>
-            </a:r>
-            <a:endParaRPr lang="en-US" sz="2500" dirty="0"/>
+              <a:t>We read the notes with the numbers — and we know when the</a:t>
+            </a:r>
+            <a:endParaRPr lang="en-US" sz="2400" dirty="0"/>
           </a:p>
           <a:p>
             <a:pPr indent="0" marL="0">
               <a:lnSpc>
-                <a:spcPts val="4000"/>
+                <a:spcPts val="3600"/>
               </a:lnSpc>
               <a:buNone/>
             </a:pPr>
             <a:r>
-              <a:rPr lang="en-US" sz="2500" dirty="0">
+              <a:rPr lang="en-US" sz="2400" dirty="0">
                 <a:solidFill>
                   <a:srgbClr val="FFFFFF"/>
                 </a:solidFill>
@@ -3210,19 +3178,179 @@
                 <a:ea typeface="Calibri" pitchFamily="34" charset="-122"/>
                 <a:cs typeface="Calibri" pitchFamily="34" charset="-120"/>
               </a:rPr>
-              <a:t> </a:t>
-            </a:r>
-            <a:endParaRPr lang="en-US" sz="2500" dirty="0"/>
-          </a:p>
+              <a:t>right answer is still the wrong thing to say.</a:t>
+            </a:r>
+            <a:endParaRPr lang="en-US" sz="2400" dirty="0"/>
+          </a:p>
+        </p:txBody>
+      </p:sp>
+      <p:sp>
+        <p:nvSpPr>
+          <p:cNvPr id="6" name="Shape 4"/>
+          <p:cNvSpPr/>
+          <p:nvPr/>
+        </p:nvSpPr>
+        <p:spPr>
+          <a:xfrm>
+            <a:off x="822960" y="4846320"/>
+            <a:ext cx="10789920" cy="12802"/>
+          </a:xfrm>
+          <a:prstGeom prst="rect">
+            <a:avLst/>
+          </a:prstGeom>
+          <a:solidFill>
+            <a:srgbClr val="C9A94A"/>
+          </a:solidFill>
+          <a:ln/>
+        </p:spPr>
+      </p:sp>
+      <p:sp>
+        <p:nvSpPr>
+          <p:cNvPr id="7" name="Shape 5"/>
+          <p:cNvSpPr/>
+          <p:nvPr/>
+        </p:nvSpPr>
+        <p:spPr>
+          <a:xfrm>
+            <a:off x="822960" y="5102352"/>
+            <a:ext cx="457200" cy="10973"/>
+          </a:xfrm>
+          <a:prstGeom prst="rect">
+            <a:avLst/>
+          </a:prstGeom>
+          <a:solidFill>
+            <a:srgbClr val="C9A94A"/>
+          </a:solidFill>
+          <a:ln/>
+        </p:spPr>
+      </p:sp>
+      <p:sp>
+        <p:nvSpPr>
+          <p:cNvPr id="8" name="Text 6"/>
+          <p:cNvSpPr txBox="1"/>
+          <p:nvPr/>
+        </p:nvSpPr>
+        <p:spPr>
+          <a:xfrm>
+            <a:off x="822960" y="5230368"/>
+            <a:ext cx="2560320" cy="457200"/>
+          </a:xfrm>
+          <a:prstGeom prst="rect">
+            <a:avLst/>
+          </a:prstGeom>
+          <a:noFill/>
+          <a:ln/>
+        </p:spPr>
+        <p:txBody>
+          <a:bodyPr wrap="square" lIns="0" tIns="0" rIns="0" bIns="0" rtlCol="0" anchor="ctr"/>
+          <a:lstStyle/>
+          <a:p>
+            <a:pPr indent="0" marL="0">
+              <a:buNone/>
+            </a:pPr>
+            <a:r>
+              <a:rPr lang="en-US" sz="2900" spc="100" kern="0" dirty="0">
+                <a:solidFill>
+                  <a:srgbClr val="FFFFFF"/>
+                </a:solidFill>
+                <a:latin typeface="Calibri" pitchFamily="34" charset="0"/>
+                <a:ea typeface="Calibri" pitchFamily="34" charset="-122"/>
+                <a:cs typeface="Calibri" pitchFamily="34" charset="-120"/>
+              </a:rPr>
+              <a:t>7 of 20</a:t>
+            </a:r>
+            <a:endParaRPr lang="en-US" sz="2900" dirty="0"/>
+          </a:p>
+        </p:txBody>
+      </p:sp>
+      <p:sp>
+        <p:nvSpPr>
+          <p:cNvPr id="9" name="Text 7"/>
+          <p:cNvSpPr txBox="1"/>
+          <p:nvPr/>
+        </p:nvSpPr>
+        <p:spPr>
+          <a:xfrm>
+            <a:off x="822960" y="5724144"/>
+            <a:ext cx="2468880" cy="548640"/>
+          </a:xfrm>
+          <a:prstGeom prst="rect">
+            <a:avLst/>
+          </a:prstGeom>
+          <a:noFill/>
+          <a:ln/>
+        </p:spPr>
+        <p:txBody>
+          <a:bodyPr wrap="square" lIns="0" tIns="0" rIns="0" bIns="0" rtlCol="0" anchor="ctr"/>
+          <a:lstStyle/>
           <a:p>
             <a:pPr indent="0" marL="0">
               <a:lnSpc>
-                <a:spcPts val="4000"/>
+                <a:spcPts val="1600"/>
               </a:lnSpc>
               <a:buNone/>
             </a:pPr>
             <a:r>
-              <a:rPr lang="en-US" sz="2500" dirty="0">
+              <a:rPr lang="en-US" sz="1200" dirty="0">
+                <a:solidFill>
+                  <a:srgbClr val="9AAAE0"/>
+                </a:solidFill>
+                <a:latin typeface="Calibri" pitchFamily="34" charset="0"/>
+                <a:ea typeface="Calibri" pitchFamily="34" charset="-122"/>
+                <a:cs typeface="Calibri" pitchFamily="34" charset="-120"/>
+              </a:rPr>
+              <a:t>Clients where an RM note changed the answer</a:t>
+            </a:r>
+            <a:endParaRPr lang="en-US" sz="1200" dirty="0"/>
+          </a:p>
+        </p:txBody>
+      </p:sp>
+      <p:sp>
+        <p:nvSpPr>
+          <p:cNvPr id="10" name="Shape 8"/>
+          <p:cNvSpPr/>
+          <p:nvPr/>
+        </p:nvSpPr>
+        <p:spPr>
+          <a:xfrm>
+            <a:off x="3547872" y="5102352"/>
+            <a:ext cx="457200" cy="10973"/>
+          </a:xfrm>
+          <a:prstGeom prst="rect">
+            <a:avLst/>
+          </a:prstGeom>
+          <a:solidFill>
+            <a:srgbClr val="C9A94A"/>
+          </a:solidFill>
+          <a:ln/>
+        </p:spPr>
+      </p:sp>
+      <p:sp>
+        <p:nvSpPr>
+          <p:cNvPr id="11" name="Text 9"/>
+          <p:cNvSpPr txBox="1"/>
+          <p:nvPr/>
+        </p:nvSpPr>
+        <p:spPr>
+          <a:xfrm>
+            <a:off x="3547872" y="5230368"/>
+            <a:ext cx="2560320" cy="457200"/>
+          </a:xfrm>
+          <a:prstGeom prst="rect">
+            <a:avLst/>
+          </a:prstGeom>
+          <a:noFill/>
+          <a:ln/>
+        </p:spPr>
+        <p:txBody>
+          <a:bodyPr wrap="square" lIns="0" tIns="0" rIns="0" bIns="0" rtlCol="0" anchor="ctr"/>
+          <a:lstStyle/>
+          <a:p>
+            <a:pPr indent="0" marL="0">
+              <a:buNone/>
+            </a:pPr>
+            <a:r>
+              <a:rPr lang="en-US" sz="2900" spc="100" kern="0" dirty="0">
                 <a:solidFill>
                   <a:srgbClr val="FFFFFF"/>
                 </a:solidFill>
@@ -3230,19 +3358,100 @@
                 <a:ea typeface="Calibri" pitchFamily="34" charset="-122"/>
                 <a:cs typeface="Calibri" pitchFamily="34" charset="-120"/>
               </a:rPr>
-              <a:t>We read the notes with the numbers — and we know when the</a:t>
-            </a:r>
-            <a:endParaRPr lang="en-US" sz="2500" dirty="0"/>
-          </a:p>
+              <a:t>6</a:t>
+            </a:r>
+            <a:endParaRPr lang="en-US" sz="2900" dirty="0"/>
+          </a:p>
+        </p:txBody>
+      </p:sp>
+      <p:sp>
+        <p:nvSpPr>
+          <p:cNvPr id="12" name="Text 10"/>
+          <p:cNvSpPr txBox="1"/>
+          <p:nvPr/>
+        </p:nvSpPr>
+        <p:spPr>
+          <a:xfrm>
+            <a:off x="3547872" y="5724144"/>
+            <a:ext cx="2468880" cy="548640"/>
+          </a:xfrm>
+          <a:prstGeom prst="rect">
+            <a:avLst/>
+          </a:prstGeom>
+          <a:noFill/>
+          <a:ln/>
+        </p:spPr>
+        <p:txBody>
+          <a:bodyPr wrap="square" lIns="0" tIns="0" rIns="0" bIns="0" rtlCol="0" anchor="ctr"/>
+          <a:lstStyle/>
           <a:p>
             <a:pPr indent="0" marL="0">
               <a:lnSpc>
-                <a:spcPts val="4000"/>
+                <a:spcPts val="1600"/>
               </a:lnSpc>
               <a:buNone/>
             </a:pPr>
             <a:r>
-              <a:rPr lang="en-US" sz="2500" dirty="0">
+              <a:rPr lang="en-US" sz="1200" dirty="0">
+                <a:solidFill>
+                  <a:srgbClr val="9AAAE0"/>
+                </a:solidFill>
+                <a:latin typeface="Calibri" pitchFamily="34" charset="0"/>
+                <a:ea typeface="Calibri" pitchFamily="34" charset="-122"/>
+                <a:cs typeface="Calibri" pitchFamily="34" charset="-120"/>
+              </a:rPr>
+              <a:t>Findings held, each with a reason and a revisit date</a:t>
+            </a:r>
+            <a:endParaRPr lang="en-US" sz="1200" dirty="0"/>
+          </a:p>
+        </p:txBody>
+      </p:sp>
+      <p:sp>
+        <p:nvSpPr>
+          <p:cNvPr id="13" name="Shape 11"/>
+          <p:cNvSpPr/>
+          <p:nvPr/>
+        </p:nvSpPr>
+        <p:spPr>
+          <a:xfrm>
+            <a:off x="6272784" y="5102352"/>
+            <a:ext cx="457200" cy="10973"/>
+          </a:xfrm>
+          <a:prstGeom prst="rect">
+            <a:avLst/>
+          </a:prstGeom>
+          <a:solidFill>
+            <a:srgbClr val="C9A94A"/>
+          </a:solidFill>
+          <a:ln/>
+        </p:spPr>
+      </p:sp>
+      <p:sp>
+        <p:nvSpPr>
+          <p:cNvPr id="14" name="Text 12"/>
+          <p:cNvSpPr txBox="1"/>
+          <p:nvPr/>
+        </p:nvSpPr>
+        <p:spPr>
+          <a:xfrm>
+            <a:off x="6272784" y="5230368"/>
+            <a:ext cx="2560320" cy="457200"/>
+          </a:xfrm>
+          <a:prstGeom prst="rect">
+            <a:avLst/>
+          </a:prstGeom>
+          <a:noFill/>
+          <a:ln/>
+        </p:spPr>
+        <p:txBody>
+          <a:bodyPr wrap="square" lIns="0" tIns="0" rIns="0" bIns="0" rtlCol="0" anchor="ctr"/>
+          <a:lstStyle/>
+          <a:p>
+            <a:pPr indent="0" marL="0">
+              <a:buNone/>
+            </a:pPr>
+            <a:r>
+              <a:rPr lang="en-US" sz="2900" spc="100" kern="0" dirty="0">
                 <a:solidFill>
                   <a:srgbClr val="FFFFFF"/>
                 </a:solidFill>
@@ -3250,40 +3459,183 @@
                 <a:ea typeface="Calibri" pitchFamily="34" charset="-122"/>
                 <a:cs typeface="Calibri" pitchFamily="34" charset="-120"/>
               </a:rPr>
-              <a:t>right answer is still the wrong thing to say.</a:t>
-            </a:r>
-            <a:endParaRPr lang="en-US" sz="2500" dirty="0"/>
-          </a:p>
-        </p:txBody>
-      </p:sp>
-      <p:sp>
-        <p:nvSpPr>
-          <p:cNvPr id="4" name="Text 2"/>
-          <p:cNvSpPr txBox="1"/>
-          <p:nvPr/>
-        </p:nvSpPr>
-        <p:spPr>
-          <a:xfrm>
-            <a:off x="822960" y="5669280"/>
-            <a:ext cx="10515600" cy="365760"/>
-          </a:xfrm>
-          <a:prstGeom prst="rect">
-            <a:avLst/>
-          </a:prstGeom>
-          <a:noFill/>
-          <a:ln/>
-        </p:spPr>
-        <p:txBody>
-          <a:bodyPr wrap="square" lIns="0" tIns="0" rIns="0" bIns="0" rtlCol="0" anchor="ctr"/>
-          <a:lstStyle/>
-          <a:p>
-            <a:pPr indent="0" marL="0">
-              <a:buNone/>
-            </a:pPr>
-            <a:r>
-              <a:rPr lang="en-US" sz="1450" dirty="0">
-                <a:solidFill>
-                  <a:srgbClr val="7186D3"/>
+              <a:t>48</a:t>
+            </a:r>
+            <a:endParaRPr lang="en-US" sz="2900" dirty="0"/>
+          </a:p>
+        </p:txBody>
+      </p:sp>
+      <p:sp>
+        <p:nvSpPr>
+          <p:cNvPr id="15" name="Text 13"/>
+          <p:cNvSpPr txBox="1"/>
+          <p:nvPr/>
+        </p:nvSpPr>
+        <p:spPr>
+          <a:xfrm>
+            <a:off x="6272784" y="5724144"/>
+            <a:ext cx="2468880" cy="548640"/>
+          </a:xfrm>
+          <a:prstGeom prst="rect">
+            <a:avLst/>
+          </a:prstGeom>
+          <a:noFill/>
+          <a:ln/>
+        </p:spPr>
+        <p:txBody>
+          <a:bodyPr wrap="square" lIns="0" tIns="0" rIns="0" bIns="0" rtlCol="0" anchor="ctr"/>
+          <a:lstStyle/>
+          <a:p>
+            <a:pPr indent="0" marL="0">
+              <a:lnSpc>
+                <a:spcPts val="1600"/>
+              </a:lnSpc>
+              <a:buNone/>
+            </a:pPr>
+            <a:r>
+              <a:rPr lang="en-US" sz="1200" dirty="0">
+                <a:solidFill>
+                  <a:srgbClr val="9AAAE0"/>
+                </a:solidFill>
+                <a:latin typeface="Calibri" pitchFamily="34" charset="0"/>
+                <a:ea typeface="Calibri" pitchFamily="34" charset="-122"/>
+                <a:cs typeface="Calibri" pitchFamily="34" charset="-120"/>
+              </a:rPr>
+              <a:t>Findings this cycle, produced by six agents</a:t>
+            </a:r>
+            <a:endParaRPr lang="en-US" sz="1200" dirty="0"/>
+          </a:p>
+        </p:txBody>
+      </p:sp>
+      <p:sp>
+        <p:nvSpPr>
+          <p:cNvPr id="16" name="Shape 14"/>
+          <p:cNvSpPr/>
+          <p:nvPr/>
+        </p:nvSpPr>
+        <p:spPr>
+          <a:xfrm>
+            <a:off x="8997696" y="5102352"/>
+            <a:ext cx="457200" cy="10973"/>
+          </a:xfrm>
+          <a:prstGeom prst="rect">
+            <a:avLst/>
+          </a:prstGeom>
+          <a:solidFill>
+            <a:srgbClr val="C9A94A"/>
+          </a:solidFill>
+          <a:ln/>
+        </p:spPr>
+      </p:sp>
+      <p:sp>
+        <p:nvSpPr>
+          <p:cNvPr id="17" name="Text 15"/>
+          <p:cNvSpPr txBox="1"/>
+          <p:nvPr/>
+        </p:nvSpPr>
+        <p:spPr>
+          <a:xfrm>
+            <a:off x="8997696" y="5230368"/>
+            <a:ext cx="2560320" cy="457200"/>
+          </a:xfrm>
+          <a:prstGeom prst="rect">
+            <a:avLst/>
+          </a:prstGeom>
+          <a:noFill/>
+          <a:ln/>
+        </p:spPr>
+        <p:txBody>
+          <a:bodyPr wrap="square" lIns="0" tIns="0" rIns="0" bIns="0" rtlCol="0" anchor="ctr"/>
+          <a:lstStyle/>
+          <a:p>
+            <a:pPr indent="0" marL="0">
+              <a:buNone/>
+            </a:pPr>
+            <a:r>
+              <a:rPr lang="en-US" sz="2900" spc="100" kern="0" dirty="0">
+                <a:solidFill>
+                  <a:srgbClr val="FFFFFF"/>
+                </a:solidFill>
+                <a:latin typeface="Calibri" pitchFamily="34" charset="0"/>
+                <a:ea typeface="Calibri" pitchFamily="34" charset="-122"/>
+                <a:cs typeface="Calibri" pitchFamily="34" charset="-120"/>
+              </a:rPr>
+              <a:t>USD 8.50m</a:t>
+            </a:r>
+            <a:endParaRPr lang="en-US" sz="2900" dirty="0"/>
+          </a:p>
+        </p:txBody>
+      </p:sp>
+      <p:sp>
+        <p:nvSpPr>
+          <p:cNvPr id="18" name="Text 16"/>
+          <p:cNvSpPr txBox="1"/>
+          <p:nvPr/>
+        </p:nvSpPr>
+        <p:spPr>
+          <a:xfrm>
+            <a:off x="8997696" y="5724144"/>
+            <a:ext cx="2468880" cy="548640"/>
+          </a:xfrm>
+          <a:prstGeom prst="rect">
+            <a:avLst/>
+          </a:prstGeom>
+          <a:noFill/>
+          <a:ln/>
+        </p:spPr>
+        <p:txBody>
+          <a:bodyPr wrap="square" lIns="0" tIns="0" rIns="0" bIns="0" rtlCol="0" anchor="ctr"/>
+          <a:lstStyle/>
+          <a:p>
+            <a:pPr indent="0" marL="0">
+              <a:lnSpc>
+                <a:spcPts val="1600"/>
+              </a:lnSpc>
+              <a:buNone/>
+            </a:pPr>
+            <a:r>
+              <a:rPr lang="en-US" sz="1200" dirty="0">
+                <a:solidFill>
+                  <a:srgbClr val="9AAAE0"/>
+                </a:solidFill>
+                <a:latin typeface="Calibri" pitchFamily="34" charset="0"/>
+                <a:ea typeface="Calibri" pitchFamily="34" charset="-122"/>
+                <a:cs typeface="Calibri" pitchFamily="34" charset="-120"/>
+              </a:rPr>
+              <a:t>Idle cash above mandate, deployable today</a:t>
+            </a:r>
+            <a:endParaRPr lang="en-US" sz="1200" dirty="0"/>
+          </a:p>
+        </p:txBody>
+      </p:sp>
+      <p:sp>
+        <p:nvSpPr>
+          <p:cNvPr id="19" name="Text 17"/>
+          <p:cNvSpPr txBox="1"/>
+          <p:nvPr/>
+        </p:nvSpPr>
+        <p:spPr>
+          <a:xfrm>
+            <a:off x="822960" y="6382512"/>
+            <a:ext cx="10515600" cy="310896"/>
+          </a:xfrm>
+          <a:prstGeom prst="rect">
+            <a:avLst/>
+          </a:prstGeom>
+          <a:noFill/>
+          <a:ln/>
+        </p:spPr>
+        <p:txBody>
+          <a:bodyPr wrap="square" lIns="0" tIns="0" rIns="0" bIns="0" rtlCol="0" anchor="ctr"/>
+          <a:lstStyle/>
+          <a:p>
+            <a:pPr indent="0" marL="0">
+              <a:buNone/>
+            </a:pPr>
+            <a:r>
+              <a:rPr lang="en-US" sz="1350" dirty="0">
+                <a:solidFill>
+                  <a:srgbClr val="6E86D8"/>
                 </a:solidFill>
                 <a:latin typeface="Calibri" pitchFamily="34" charset="0"/>
                 <a:ea typeface="Calibri" pitchFamily="34" charset="-122"/>
@@ -3291,7 +3643,7 @@
               </a:rPr>
               <a:t>github.com/jvvinoth/Foresight-RM</a:t>
             </a:r>
-            <a:endParaRPr lang="en-US" sz="1450" dirty="0"/>
+            <a:endParaRPr lang="en-US" sz="1350" dirty="0"/>
           </a:p>
         </p:txBody>
       </p:sp>

</xml_diff>

<commit_message>
deck: correct the mandate limit on slide 3 — 12%, not 10%
Lau's portfolio PF-0016 runs mandate BAL (Balanced), whose
max_single_position_pct is 12.0. The slide asserted 10%, which is the
CONS/INC figure and belongs to a different mandate.

The comparison was also apples-to-oranges: 49.0% is the aggregate across
four correlated positions, while max_single_position_pct governs one
position. Reframed to what the engine actually reports — three positions
individually breach the 12% limit (19.58%, 17.57%, 12.87%), and the 49%
aggregate is measured by no mandate rule at all. That gap is the finding.

Co-Authored-By: Claude Opus 5 <noreply@anthropic.com>
</commit_message>
<xml_diff>
--- a/docs/Foresight-RM-Pitch.pptx
+++ b/docs/Foresight-RM-Pitch.pptx
@@ -953,7 +953,7 @@
           <a:p>
             <a:r>
               <a:rPr lang="en-US" dirty="0"/>
-              <a:t>One click resolves the six positions into a single correlated bet: 49.0% of wealth against a 10% single-position limit, plus three exposures held outside the portfolio entirely. Pause after the limit figure.</a:t>
+              <a:t>One click resolves the six positions into a single correlated bet. His mandate is Balanced, so the single-position limit is 12% (mandates.csv, BAL) — and three positions already breach it: the Mid-Levels apartment at 19.58%, a Pacific Rim Bank perpetual at 17.57%, and the Golden Harbour perpetual at 12.87%. The 49% is the aggregate across four correlated positions, which no mandate rule measures at all. That gap is the point. Pause after the limit figure.</a:t>
             </a:r>
             <a:endParaRPr lang="en-US" dirty="0"/>
           </a:p>
@@ -4228,24 +4228,27 @@
         </p:nvSpPr>
         <p:spPr>
           <a:xfrm>
-            <a:off x="5623560" y="3977640"/>
-            <a:ext cx="5943600" cy="365760"/>
-          </a:xfrm>
-          <a:prstGeom prst="rect">
-            <a:avLst/>
-          </a:prstGeom>
-          <a:noFill/>
-          <a:ln/>
-        </p:spPr>
-        <p:txBody>
-          <a:bodyPr wrap="square" lIns="0" tIns="0" rIns="0" bIns="0" rtlCol="0" anchor="ctr"/>
-          <a:lstStyle/>
-          <a:p>
-            <a:pPr indent="0" marL="0">
-              <a:buNone/>
-            </a:pPr>
-            <a:r>
-              <a:rPr lang="en-US" sz="1450" spc="100" kern="0" dirty="0">
+            <a:off x="5623560" y="3931920"/>
+            <a:ext cx="5943600" cy="685800"/>
+          </a:xfrm>
+          <a:prstGeom prst="rect">
+            <a:avLst/>
+          </a:prstGeom>
+          <a:noFill/>
+          <a:ln/>
+        </p:spPr>
+        <p:txBody>
+          <a:bodyPr wrap="square" lIns="0" tIns="0" rIns="0" bIns="0" rtlCol="0" anchor="ctr"/>
+          <a:lstStyle/>
+          <a:p>
+            <a:pPr indent="0" marL="0">
+              <a:lnSpc>
+                <a:spcPts val="2200"/>
+              </a:lnSpc>
+              <a:buNone/>
+            </a:pPr>
+            <a:r>
+              <a:rPr lang="en-US" sz="1450" spc="80" kern="0" dirty="0">
                 <a:solidFill>
                   <a:srgbClr val="C9A94A"/>
                 </a:solidFill>
@@ -4253,7 +4256,7 @@
                 <a:ea typeface="Calibri" pitchFamily="34" charset="-122"/>
                 <a:cs typeface="Calibri" pitchFamily="34" charset="-120"/>
               </a:rPr>
-              <a:t>Mandate limit for a single position: 10%</a:t>
+              <a:t>Three positions already breach the 12% single-position limit — and no mandate rule measures the other 49%</a:t>
             </a:r>
             <a:endParaRPr lang="en-US" sz="1450" dirty="0"/>
           </a:p>

</xml_diff>

<commit_message>
correct the "revisit date" overclaim on held findings
Only one of the three held conflicts actually carries a revisit date
(Yamamoto, November 2026). Margarethe's and Tan Boon Huat's are both null,
because the client instruction behind each is open-ended.

The dashboard tile and slide 12 both asserted "with reason and revisit
date" for all of them. What is true of every hold is that it carries a
reason and a dated, attributed RM note — N-005, N-015, N-021 — so that is
what they now say. Slide 6's speaker note flags that this particular hold
has no revisit date, in case a judge asks to see one.

Co-Authored-By: Claude Opus 5 <noreply@anthropic.com>
</commit_message>
<xml_diff>
--- a/docs/Foresight-RM-Pitch.pptx
+++ b/docs/Foresight-RM-Pitch.pptx
@@ -777,7 +777,7 @@
           <a:p>
             <a:r>
               <a:rPr lang="en-US" dirty="0"/>
-              <a:t>Close on the three sentences, then let the four numbers sit on screen through questions. Every one of them is read from the run, not asserted: seven of twenty clients had an RM note change the answer, six findings were held with a reason and a revisit date, forty-eight findings came from six agents, and USD 8.50m of idle cash sits above mandate.</a:t>
+              <a:t>Close on the three sentences, then let the four numbers sit on screen through questions. Every one of them is read from the run, not asserted: seven of twenty clients had an RM note change the answer, six findings were held with a reason and a dated RM note, forty-eight findings came from six agents, and USD 8.50m of idle cash sits above mandate.</a:t>
             </a:r>
             <a:endParaRPr lang="en-US" dirty="0"/>
           </a:p>
@@ -1217,7 +1217,7 @@
           <a:p>
             <a:r>
               <a:rPr lang="en-US" dirty="0"/>
-              <a:t>Suitability correctly identifies a critical breach. The Relationship agent objects on a dated client instruction, and the gate holds the finding with a reason and a revisit date. The system can overrule its own analysis when a human fact requires it.</a:t>
+              <a:t>Suitability correctly identifies a critical breach. The Relationship agent objects on a dated client instruction, and the gate holds the finding with a reason and a dated note. Only some holds carry a revisit date; this one does not, because the instruction was open-ended. The system can overrule its own analysis when a human fact requires it.</a:t>
             </a:r>
             <a:endParaRPr lang="en-US" dirty="0"/>
           </a:p>
@@ -3400,7 +3400,7 @@
                 <a:ea typeface="Calibri" pitchFamily="34" charset="-122"/>
                 <a:cs typeface="Calibri" pitchFamily="34" charset="-120"/>
               </a:rPr>
-              <a:t>Findings held, each with a reason and a revisit date</a:t>
+              <a:t>Findings held, each with a reason and a dated RM note</a:t>
             </a:r>
             <a:endParaRPr lang="en-US" sz="1200" dirty="0"/>
           </a:p>

</xml_diff>